<commit_message>
exercises.html all-slides-with-answers.pdf all-slides.pdf code.zip linear_programming.pdf linear_programming.pptx numpy.pdf numpy.pptx
</commit_message>
<xml_diff>
--- a/ipsa/slides/linear_programming.pptx
+++ b/ipsa/slides/linear_programming.pptx
@@ -5,7 +5,7 @@
     <p:sldMasterId id="2147483648" r:id="rId1"/>
   </p:sldMasterIdLst>
   <p:notesMasterIdLst>
-    <p:notesMasterId r:id="rId28"/>
+    <p:notesMasterId r:id="rId27"/>
   </p:notesMasterIdLst>
   <p:sldIdLst>
     <p:sldId id="771" r:id="rId2"/>
@@ -28,12 +28,11 @@
     <p:sldId id="796" r:id="rId19"/>
     <p:sldId id="793" r:id="rId20"/>
     <p:sldId id="773" r:id="rId21"/>
-    <p:sldId id="799" r:id="rId22"/>
-    <p:sldId id="774" r:id="rId23"/>
-    <p:sldId id="775" r:id="rId24"/>
-    <p:sldId id="797" r:id="rId25"/>
-    <p:sldId id="798" r:id="rId26"/>
-    <p:sldId id="800" r:id="rId27"/>
+    <p:sldId id="774" r:id="rId22"/>
+    <p:sldId id="775" r:id="rId23"/>
+    <p:sldId id="797" r:id="rId24"/>
+    <p:sldId id="798" r:id="rId25"/>
+    <p:sldId id="800" r:id="rId26"/>
   </p:sldIdLst>
   <p:sldSz cx="12192000" cy="6858000"/>
   <p:notesSz cx="6858000" cy="9144000"/>
@@ -152,8 +151,8 @@
 <pc:chgInfo xmlns:a="http://schemas.openxmlformats.org/drawingml/2006/main" xmlns:r="http://schemas.openxmlformats.org/officeDocument/2006/relationships" xmlns:ac="http://schemas.microsoft.com/office/drawing/2013/main/command" xmlns:pc="http://schemas.microsoft.com/office/powerpoint/2013/main/command">
   <pc:docChgLst>
     <pc:chgData name="Gerth Stølting Brodal" userId="04ef4784-6591-4f86-a140-f5c3b108582a" providerId="ADAL" clId="{73BAC7D6-516A-44B5-B4B0-C7B08CA8B392}"/>
-    <pc:docChg chg="undo redo custSel addSld modSld">
-      <pc:chgData name="Gerth Stølting Brodal" userId="04ef4784-6591-4f86-a140-f5c3b108582a" providerId="ADAL" clId="{73BAC7D6-516A-44B5-B4B0-C7B08CA8B392}" dt="2026-04-12T22:32:04.130" v="3012" actId="6549"/>
+    <pc:docChg chg="undo redo custSel addSld delSld modSld">
+      <pc:chgData name="Gerth Stølting Brodal" userId="04ef4784-6591-4f86-a140-f5c3b108582a" providerId="ADAL" clId="{73BAC7D6-516A-44B5-B4B0-C7B08CA8B392}" dt="2026-04-13T08:13:57.206" v="3013" actId="47"/>
       <pc:docMkLst>
         <pc:docMk/>
       </pc:docMkLst>
@@ -1526,8 +1525,8 @@
           </ac:picMkLst>
         </pc:picChg>
       </pc:sldChg>
-      <pc:sldChg chg="addSp delSp modSp new mod modAnim">
-        <pc:chgData name="Gerth Stølting Brodal" userId="04ef4784-6591-4f86-a140-f5c3b108582a" providerId="ADAL" clId="{73BAC7D6-516A-44B5-B4B0-C7B08CA8B392}" dt="2026-04-12T12:12:01.072" v="1143" actId="1037"/>
+      <pc:sldChg chg="addSp delSp modSp new del mod modAnim">
+        <pc:chgData name="Gerth Stølting Brodal" userId="04ef4784-6591-4f86-a140-f5c3b108582a" providerId="ADAL" clId="{73BAC7D6-516A-44B5-B4B0-C7B08CA8B392}" dt="2026-04-13T08:13:57.206" v="3013" actId="47"/>
         <pc:sldMkLst>
           <pc:docMk/>
           <pc:sldMk cId="481070028" sldId="799"/>
@@ -1851,7 +1850,7 @@
           <a:p>
             <a:fld id="{FB1A172F-81D4-4DC4-9113-1DBD56EC3646}" type="datetimeFigureOut">
               <a:rPr lang="en-US" smtClean="0"/>
-              <a:t>4/12/2026</a:t>
+              <a:t>4/13/2026</a:t>
             </a:fld>
             <a:endParaRPr lang="en-US"/>
           </a:p>
@@ -2457,7 +2456,7 @@
           <a:p>
             <a:fld id="{CD563DD8-32AB-41BE-B1C6-8EAC45222ACE}" type="slidenum">
               <a:rPr lang="en-US" smtClean="0"/>
-              <a:t>24</a:t>
+              <a:t>23</a:t>
             </a:fld>
             <a:endParaRPr lang="en-US"/>
           </a:p>
@@ -2727,7 +2726,7 @@
           <a:p>
             <a:fld id="{CD563DD8-32AB-41BE-B1C6-8EAC45222ACE}" type="slidenum">
               <a:rPr lang="en-US" smtClean="0"/>
-              <a:t>25</a:t>
+              <a:t>24</a:t>
             </a:fld>
             <a:endParaRPr lang="en-US"/>
           </a:p>
@@ -2835,7 +2834,7 @@
           <a:p>
             <a:fld id="{CD563DD8-32AB-41BE-B1C6-8EAC45222ACE}" type="slidenum">
               <a:rPr lang="en-US" smtClean="0"/>
-              <a:t>26</a:t>
+              <a:t>25</a:t>
             </a:fld>
             <a:endParaRPr lang="en-US"/>
           </a:p>
@@ -3894,7 +3893,7 @@
           <a:p>
             <a:fld id="{0560A9CD-0304-4E0B-9E82-E7E0115DE05B}" type="datetimeFigureOut">
               <a:rPr lang="en-US" smtClean="0"/>
-              <a:t>4/12/2026</a:t>
+              <a:t>4/13/2026</a:t>
             </a:fld>
             <a:endParaRPr lang="en-US"/>
           </a:p>
@@ -4062,7 +4061,7 @@
           <a:p>
             <a:fld id="{0560A9CD-0304-4E0B-9E82-E7E0115DE05B}" type="datetimeFigureOut">
               <a:rPr lang="en-US" smtClean="0"/>
-              <a:t>4/12/2026</a:t>
+              <a:t>4/13/2026</a:t>
             </a:fld>
             <a:endParaRPr lang="en-US"/>
           </a:p>
@@ -4240,7 +4239,7 @@
           <a:p>
             <a:fld id="{0560A9CD-0304-4E0B-9E82-E7E0115DE05B}" type="datetimeFigureOut">
               <a:rPr lang="en-US" smtClean="0"/>
-              <a:t>4/12/2026</a:t>
+              <a:t>4/13/2026</a:t>
             </a:fld>
             <a:endParaRPr lang="en-US"/>
           </a:p>
@@ -4423,7 +4422,7 @@
           <a:p>
             <a:fld id="{0560A9CD-0304-4E0B-9E82-E7E0115DE05B}" type="datetimeFigureOut">
               <a:rPr lang="en-US" smtClean="0"/>
-              <a:t>4/12/2026</a:t>
+              <a:t>4/13/2026</a:t>
             </a:fld>
             <a:endParaRPr lang="en-US"/>
           </a:p>
@@ -4668,7 +4667,7 @@
           <a:p>
             <a:fld id="{0560A9CD-0304-4E0B-9E82-E7E0115DE05B}" type="datetimeFigureOut">
               <a:rPr lang="en-US" smtClean="0"/>
-              <a:t>4/12/2026</a:t>
+              <a:t>4/13/2026</a:t>
             </a:fld>
             <a:endParaRPr lang="en-US"/>
           </a:p>
@@ -4897,7 +4896,7 @@
           <a:p>
             <a:fld id="{0560A9CD-0304-4E0B-9E82-E7E0115DE05B}" type="datetimeFigureOut">
               <a:rPr lang="en-US" smtClean="0"/>
-              <a:t>4/12/2026</a:t>
+              <a:t>4/13/2026</a:t>
             </a:fld>
             <a:endParaRPr lang="en-US"/>
           </a:p>
@@ -5261,7 +5260,7 @@
           <a:p>
             <a:fld id="{0560A9CD-0304-4E0B-9E82-E7E0115DE05B}" type="datetimeFigureOut">
               <a:rPr lang="en-US" smtClean="0"/>
-              <a:t>4/12/2026</a:t>
+              <a:t>4/13/2026</a:t>
             </a:fld>
             <a:endParaRPr lang="en-US"/>
           </a:p>
@@ -5378,7 +5377,7 @@
           <a:p>
             <a:fld id="{0560A9CD-0304-4E0B-9E82-E7E0115DE05B}" type="datetimeFigureOut">
               <a:rPr lang="en-US" smtClean="0"/>
-              <a:t>4/12/2026</a:t>
+              <a:t>4/13/2026</a:t>
             </a:fld>
             <a:endParaRPr lang="en-US"/>
           </a:p>
@@ -5473,7 +5472,7 @@
           <a:p>
             <a:fld id="{0560A9CD-0304-4E0B-9E82-E7E0115DE05B}" type="datetimeFigureOut">
               <a:rPr lang="en-US" smtClean="0"/>
-              <a:t>4/12/2026</a:t>
+              <a:t>4/13/2026</a:t>
             </a:fld>
             <a:endParaRPr lang="en-US"/>
           </a:p>
@@ -5748,7 +5747,7 @@
           <a:p>
             <a:fld id="{0560A9CD-0304-4E0B-9E82-E7E0115DE05B}" type="datetimeFigureOut">
               <a:rPr lang="en-US" smtClean="0"/>
-              <a:t>4/12/2026</a:t>
+              <a:t>4/13/2026</a:t>
             </a:fld>
             <a:endParaRPr lang="en-US"/>
           </a:p>
@@ -6000,7 +5999,7 @@
           <a:p>
             <a:fld id="{0560A9CD-0304-4E0B-9E82-E7E0115DE05B}" type="datetimeFigureOut">
               <a:rPr lang="en-US" smtClean="0"/>
-              <a:t>4/12/2026</a:t>
+              <a:t>4/13/2026</a:t>
             </a:fld>
             <a:endParaRPr lang="en-US"/>
           </a:p>
@@ -6211,7 +6210,7 @@
           <a:p>
             <a:fld id="{0560A9CD-0304-4E0B-9E82-E7E0115DE05B}" type="datetimeFigureOut">
               <a:rPr lang="en-US" smtClean="0"/>
-              <a:t>4/12/2026</a:t>
+              <a:t>4/13/2026</a:t>
             </a:fld>
             <a:endParaRPr lang="en-US"/>
           </a:p>
@@ -7788,8 +7787,8 @@
           </a:p>
         </p:txBody>
       </p:sp>
-      <mc:AlternateContent xmlns:mc="http://schemas.openxmlformats.org/markup-compatibility/2006">
-        <mc:Choice xmlns:a14="http://schemas.microsoft.com/office/drawing/2010/main" Requires="a14">
+      <mc:AlternateContent xmlns:mc="http://schemas.openxmlformats.org/markup-compatibility/2006" xmlns:a14="http://schemas.microsoft.com/office/drawing/2010/main">
+        <mc:Choice Requires="a14">
           <p:sp>
             <p:nvSpPr>
               <p:cNvPr id="3" name="Content Placeholder 2"/>
@@ -8858,7 +8857,7 @@
             </p:txBody>
           </p:sp>
         </mc:Choice>
-        <mc:Fallback>
+        <mc:Fallback xmlns="">
           <p:sp>
             <p:nvSpPr>
               <p:cNvPr id="3" name="Content Placeholder 2"/>
@@ -14659,8 +14658,8 @@
           </a:p>
         </p:txBody>
       </p:sp>
-      <mc:AlternateContent xmlns:mc="http://schemas.openxmlformats.org/markup-compatibility/2006">
-        <mc:Choice xmlns:a14="http://schemas.microsoft.com/office/drawing/2010/main" Requires="a14">
+      <mc:AlternateContent xmlns:mc="http://schemas.openxmlformats.org/markup-compatibility/2006" xmlns:a14="http://schemas.microsoft.com/office/drawing/2010/main">
+        <mc:Choice Requires="a14">
           <p:sp>
             <p:nvSpPr>
               <p:cNvPr id="3" name="TextBox 2"/>
@@ -14710,7 +14709,7 @@
             </p:txBody>
           </p:sp>
         </mc:Choice>
-        <mc:Fallback>
+        <mc:Fallback xmlns="">
           <p:sp>
             <p:nvSpPr>
               <p:cNvPr id="3" name="TextBox 2"/>
@@ -20074,2167 +20073,6 @@
           <a:chExt cx="0" cy="0"/>
         </a:xfrm>
       </p:grpSpPr>
-      <p:grpSp>
-        <p:nvGrpSpPr>
-          <p:cNvPr id="4" name="Group 3">
-            <a:extLst>
-              <a:ext uri="{FF2B5EF4-FFF2-40B4-BE49-F238E27FC236}">
-                <a16:creationId xmlns:a16="http://schemas.microsoft.com/office/drawing/2014/main" id="{997347CE-CB50-79E5-60EB-6D1B40BA976B}"/>
-              </a:ext>
-            </a:extLst>
-          </p:cNvPr>
-          <p:cNvGrpSpPr/>
-          <p:nvPr/>
-        </p:nvGrpSpPr>
-        <p:grpSpPr>
-          <a:xfrm>
-            <a:off x="1453260" y="1518518"/>
-            <a:ext cx="9461199" cy="3593709"/>
-            <a:chOff x="1688171" y="1651683"/>
-            <a:chExt cx="9461199" cy="3593709"/>
-          </a:xfrm>
-        </p:grpSpPr>
-        <p:cxnSp>
-          <p:nvCxnSpPr>
-            <p:cNvPr id="5" name="Straight Arrow Connector 4">
-              <a:extLst>
-                <a:ext uri="{FF2B5EF4-FFF2-40B4-BE49-F238E27FC236}">
-                  <a16:creationId xmlns:a16="http://schemas.microsoft.com/office/drawing/2014/main" id="{EBD8056C-11EA-F6B7-876B-888F74CBA221}"/>
-                </a:ext>
-              </a:extLst>
-            </p:cNvPr>
-            <p:cNvCxnSpPr/>
-            <p:nvPr/>
-          </p:nvCxnSpPr>
-          <p:spPr>
-            <a:xfrm flipV="1">
-              <a:off x="2260274" y="2352661"/>
-              <a:ext cx="2050170" cy="1050218"/>
-            </a:xfrm>
-            <a:prstGeom prst="straightConnector1">
-              <a:avLst/>
-            </a:prstGeom>
-            <a:ln w="57150">
-              <a:solidFill>
-                <a:schemeClr val="tx1"/>
-              </a:solidFill>
-              <a:headEnd w="lg" len="lg"/>
-              <a:tailEnd type="triangle" w="lg" len="lg"/>
-            </a:ln>
-          </p:spPr>
-          <p:style>
-            <a:lnRef idx="1">
-              <a:schemeClr val="accent1"/>
-            </a:lnRef>
-            <a:fillRef idx="0">
-              <a:schemeClr val="accent1"/>
-            </a:fillRef>
-            <a:effectRef idx="0">
-              <a:schemeClr val="accent1"/>
-            </a:effectRef>
-            <a:fontRef idx="minor">
-              <a:schemeClr val="tx1"/>
-            </a:fontRef>
-          </p:style>
-        </p:cxnSp>
-        <p:cxnSp>
-          <p:nvCxnSpPr>
-            <p:cNvPr id="6" name="Straight Arrow Connector 5">
-              <a:extLst>
-                <a:ext uri="{FF2B5EF4-FFF2-40B4-BE49-F238E27FC236}">
-                  <a16:creationId xmlns:a16="http://schemas.microsoft.com/office/drawing/2014/main" id="{BA38CD44-B0D8-F5FA-9D11-8155E3E2F420}"/>
-                </a:ext>
-              </a:extLst>
-            </p:cNvPr>
-            <p:cNvCxnSpPr>
-              <a:endCxn id="17" idx="2"/>
-            </p:cNvCxnSpPr>
-            <p:nvPr/>
-          </p:nvCxnSpPr>
-          <p:spPr>
-            <a:xfrm>
-              <a:off x="2260274" y="3400039"/>
-              <a:ext cx="2050170" cy="1321663"/>
-            </a:xfrm>
-            <a:prstGeom prst="straightConnector1">
-              <a:avLst/>
-            </a:prstGeom>
-            <a:ln w="57150">
-              <a:solidFill>
-                <a:schemeClr val="tx1"/>
-              </a:solidFill>
-              <a:headEnd w="lg" len="lg"/>
-              <a:tailEnd type="triangle" w="lg" len="lg"/>
-            </a:ln>
-          </p:spPr>
-          <p:style>
-            <a:lnRef idx="1">
-              <a:schemeClr val="accent1"/>
-            </a:lnRef>
-            <a:fillRef idx="0">
-              <a:schemeClr val="accent1"/>
-            </a:fillRef>
-            <a:effectRef idx="0">
-              <a:schemeClr val="accent1"/>
-            </a:effectRef>
-            <a:fontRef idx="minor">
-              <a:schemeClr val="tx1"/>
-            </a:fontRef>
-          </p:style>
-        </p:cxnSp>
-        <p:cxnSp>
-          <p:nvCxnSpPr>
-            <p:cNvPr id="7" name="Straight Arrow Connector 6">
-              <a:extLst>
-                <a:ext uri="{FF2B5EF4-FFF2-40B4-BE49-F238E27FC236}">
-                  <a16:creationId xmlns:a16="http://schemas.microsoft.com/office/drawing/2014/main" id="{45C803D3-A8FF-4B94-55D4-B21E46DD6344}"/>
-                </a:ext>
-              </a:extLst>
-            </p:cNvPr>
-            <p:cNvCxnSpPr>
-              <a:endCxn id="18" idx="2"/>
-            </p:cNvCxnSpPr>
-            <p:nvPr/>
-          </p:nvCxnSpPr>
-          <p:spPr>
-            <a:xfrm>
-              <a:off x="5304134" y="4718863"/>
-              <a:ext cx="2019810" cy="2840"/>
-            </a:xfrm>
-            <a:prstGeom prst="straightConnector1">
-              <a:avLst/>
-            </a:prstGeom>
-            <a:ln w="57150">
-              <a:solidFill>
-                <a:schemeClr val="tx1"/>
-              </a:solidFill>
-              <a:headEnd w="lg" len="lg"/>
-              <a:tailEnd type="triangle" w="lg" len="lg"/>
-            </a:ln>
-          </p:spPr>
-          <p:style>
-            <a:lnRef idx="1">
-              <a:schemeClr val="accent1"/>
-            </a:lnRef>
-            <a:fillRef idx="0">
-              <a:schemeClr val="accent1"/>
-            </a:fillRef>
-            <a:effectRef idx="0">
-              <a:schemeClr val="accent1"/>
-            </a:effectRef>
-            <a:fontRef idx="minor">
-              <a:schemeClr val="tx1"/>
-            </a:fontRef>
-          </p:style>
-        </p:cxnSp>
-        <p:cxnSp>
-          <p:nvCxnSpPr>
-            <p:cNvPr id="8" name="Straight Arrow Connector 7">
-              <a:extLst>
-                <a:ext uri="{FF2B5EF4-FFF2-40B4-BE49-F238E27FC236}">
-                  <a16:creationId xmlns:a16="http://schemas.microsoft.com/office/drawing/2014/main" id="{E8B26492-0F5F-7400-4E92-513C5B484C24}"/>
-                </a:ext>
-              </a:extLst>
-            </p:cNvPr>
-            <p:cNvCxnSpPr/>
-            <p:nvPr/>
-          </p:nvCxnSpPr>
-          <p:spPr>
-            <a:xfrm>
-              <a:off x="5304133" y="2172533"/>
-              <a:ext cx="2019810" cy="2840"/>
-            </a:xfrm>
-            <a:prstGeom prst="straightConnector1">
-              <a:avLst/>
-            </a:prstGeom>
-            <a:ln w="57150">
-              <a:solidFill>
-                <a:schemeClr val="tx1"/>
-              </a:solidFill>
-              <a:headEnd w="lg" len="lg"/>
-              <a:tailEnd type="triangle" w="lg" len="lg"/>
-            </a:ln>
-          </p:spPr>
-          <p:style>
-            <a:lnRef idx="1">
-              <a:schemeClr val="accent1"/>
-            </a:lnRef>
-            <a:fillRef idx="0">
-              <a:schemeClr val="accent1"/>
-            </a:fillRef>
-            <a:effectRef idx="0">
-              <a:schemeClr val="accent1"/>
-            </a:effectRef>
-            <a:fontRef idx="minor">
-              <a:schemeClr val="tx1"/>
-            </a:fontRef>
-          </p:style>
-        </p:cxnSp>
-        <p:cxnSp>
-          <p:nvCxnSpPr>
-            <p:cNvPr id="9" name="Straight Arrow Connector 8">
-              <a:extLst>
-                <a:ext uri="{FF2B5EF4-FFF2-40B4-BE49-F238E27FC236}">
-                  <a16:creationId xmlns:a16="http://schemas.microsoft.com/office/drawing/2014/main" id="{B4DDDB5F-3C03-23A8-939B-CF7F28CF163E}"/>
-                </a:ext>
-              </a:extLst>
-            </p:cNvPr>
-            <p:cNvCxnSpPr>
-              <a:endCxn id="19" idx="1"/>
-            </p:cNvCxnSpPr>
-            <p:nvPr/>
-          </p:nvCxnSpPr>
-          <p:spPr>
-            <a:xfrm>
-              <a:off x="7821307" y="2169693"/>
-              <a:ext cx="2348741" cy="862883"/>
-            </a:xfrm>
-            <a:prstGeom prst="straightConnector1">
-              <a:avLst/>
-            </a:prstGeom>
-            <a:ln w="57150">
-              <a:solidFill>
-                <a:schemeClr val="tx1"/>
-              </a:solidFill>
-              <a:headEnd w="lg" len="lg"/>
-              <a:tailEnd type="triangle" w="lg" len="lg"/>
-            </a:ln>
-          </p:spPr>
-          <p:style>
-            <a:lnRef idx="1">
-              <a:schemeClr val="accent1"/>
-            </a:lnRef>
-            <a:fillRef idx="0">
-              <a:schemeClr val="accent1"/>
-            </a:fillRef>
-            <a:effectRef idx="0">
-              <a:schemeClr val="accent1"/>
-            </a:effectRef>
-            <a:fontRef idx="minor">
-              <a:schemeClr val="tx1"/>
-            </a:fontRef>
-          </p:style>
-        </p:cxnSp>
-        <p:cxnSp>
-          <p:nvCxnSpPr>
-            <p:cNvPr id="10" name="Straight Arrow Connector 9">
-              <a:extLst>
-                <a:ext uri="{FF2B5EF4-FFF2-40B4-BE49-F238E27FC236}">
-                  <a16:creationId xmlns:a16="http://schemas.microsoft.com/office/drawing/2014/main" id="{5C2B0EBD-E7E7-E416-18EC-1D49BEF9A648}"/>
-                </a:ext>
-              </a:extLst>
-            </p:cNvPr>
-            <p:cNvCxnSpPr>
-              <a:endCxn id="19" idx="3"/>
-            </p:cNvCxnSpPr>
-            <p:nvPr/>
-          </p:nvCxnSpPr>
-          <p:spPr>
-            <a:xfrm flipV="1">
-              <a:off x="7821306" y="3773183"/>
-              <a:ext cx="2348743" cy="945682"/>
-            </a:xfrm>
-            <a:prstGeom prst="straightConnector1">
-              <a:avLst/>
-            </a:prstGeom>
-            <a:ln w="57150">
-              <a:solidFill>
-                <a:schemeClr val="tx1"/>
-              </a:solidFill>
-              <a:headEnd w="lg" len="lg"/>
-              <a:tailEnd type="triangle" w="lg" len="lg"/>
-            </a:ln>
-          </p:spPr>
-          <p:style>
-            <a:lnRef idx="1">
-              <a:schemeClr val="accent1"/>
-            </a:lnRef>
-            <a:fillRef idx="0">
-              <a:schemeClr val="accent1"/>
-            </a:fillRef>
-            <a:effectRef idx="0">
-              <a:schemeClr val="accent1"/>
-            </a:effectRef>
-            <a:fontRef idx="minor">
-              <a:schemeClr val="tx1"/>
-            </a:fontRef>
-          </p:style>
-        </p:cxnSp>
-        <p:cxnSp>
-          <p:nvCxnSpPr>
-            <p:cNvPr id="11" name="Straight Arrow Connector 10">
-              <a:extLst>
-                <a:ext uri="{FF2B5EF4-FFF2-40B4-BE49-F238E27FC236}">
-                  <a16:creationId xmlns:a16="http://schemas.microsoft.com/office/drawing/2014/main" id="{4FD6CAA6-8B38-E83F-1341-63055EDD090F}"/>
-                </a:ext>
-              </a:extLst>
-            </p:cNvPr>
-            <p:cNvCxnSpPr>
-              <a:endCxn id="16" idx="4"/>
-            </p:cNvCxnSpPr>
-            <p:nvPr/>
-          </p:nvCxnSpPr>
-          <p:spPr>
-            <a:xfrm flipV="1">
-              <a:off x="7821306" y="2699061"/>
-              <a:ext cx="1" cy="2019802"/>
-            </a:xfrm>
-            <a:prstGeom prst="straightConnector1">
-              <a:avLst/>
-            </a:prstGeom>
-            <a:ln w="57150">
-              <a:solidFill>
-                <a:schemeClr val="tx1"/>
-              </a:solidFill>
-              <a:headEnd w="lg" len="lg"/>
-              <a:tailEnd type="triangle" w="lg" len="lg"/>
-            </a:ln>
-          </p:spPr>
-          <p:style>
-            <a:lnRef idx="1">
-              <a:schemeClr val="accent1"/>
-            </a:lnRef>
-            <a:fillRef idx="0">
-              <a:schemeClr val="accent1"/>
-            </a:fillRef>
-            <a:effectRef idx="0">
-              <a:schemeClr val="accent1"/>
-            </a:effectRef>
-            <a:fontRef idx="minor">
-              <a:schemeClr val="tx1"/>
-            </a:fontRef>
-          </p:style>
-        </p:cxnSp>
-        <p:cxnSp>
-          <p:nvCxnSpPr>
-            <p:cNvPr id="12" name="Straight Arrow Connector 11">
-              <a:extLst>
-                <a:ext uri="{FF2B5EF4-FFF2-40B4-BE49-F238E27FC236}">
-                  <a16:creationId xmlns:a16="http://schemas.microsoft.com/office/drawing/2014/main" id="{514E9C4C-EDEE-676F-49DE-905137D0B484}"/>
-                </a:ext>
-              </a:extLst>
-            </p:cNvPr>
-            <p:cNvCxnSpPr>
-              <a:endCxn id="18" idx="1"/>
-            </p:cNvCxnSpPr>
-            <p:nvPr/>
-          </p:nvCxnSpPr>
-          <p:spPr>
-            <a:xfrm>
-              <a:off x="4806770" y="2169693"/>
-              <a:ext cx="2662849" cy="2181706"/>
-            </a:xfrm>
-            <a:prstGeom prst="straightConnector1">
-              <a:avLst/>
-            </a:prstGeom>
-            <a:ln w="57150">
-              <a:solidFill>
-                <a:schemeClr val="tx1"/>
-              </a:solidFill>
-              <a:headEnd w="lg" len="lg"/>
-              <a:tailEnd type="triangle" w="lg" len="lg"/>
-            </a:ln>
-          </p:spPr>
-          <p:style>
-            <a:lnRef idx="1">
-              <a:schemeClr val="accent1"/>
-            </a:lnRef>
-            <a:fillRef idx="0">
-              <a:schemeClr val="accent1"/>
-            </a:fillRef>
-            <a:effectRef idx="0">
-              <a:schemeClr val="accent1"/>
-            </a:effectRef>
-            <a:fontRef idx="minor">
-              <a:schemeClr val="tx1"/>
-            </a:fontRef>
-          </p:style>
-        </p:cxnSp>
-        <p:cxnSp>
-          <p:nvCxnSpPr>
-            <p:cNvPr id="13" name="Straight Arrow Connector 12">
-              <a:extLst>
-                <a:ext uri="{FF2B5EF4-FFF2-40B4-BE49-F238E27FC236}">
-                  <a16:creationId xmlns:a16="http://schemas.microsoft.com/office/drawing/2014/main" id="{D1CE8FD4-D858-DFF9-78D7-3C5323C06C51}"/>
-                </a:ext>
-              </a:extLst>
-            </p:cNvPr>
-            <p:cNvCxnSpPr>
-              <a:endCxn id="16" idx="3"/>
-            </p:cNvCxnSpPr>
-            <p:nvPr/>
-          </p:nvCxnSpPr>
-          <p:spPr>
-            <a:xfrm flipV="1">
-              <a:off x="4806769" y="2545676"/>
-              <a:ext cx="2662851" cy="2081871"/>
-            </a:xfrm>
-            <a:prstGeom prst="straightConnector1">
-              <a:avLst/>
-            </a:prstGeom>
-            <a:ln w="57150">
-              <a:solidFill>
-                <a:schemeClr val="tx1"/>
-              </a:solidFill>
-              <a:headEnd w="lg" len="lg"/>
-              <a:tailEnd type="triangle" w="lg" len="lg"/>
-            </a:ln>
-          </p:spPr>
-          <p:style>
-            <a:lnRef idx="1">
-              <a:schemeClr val="accent1"/>
-            </a:lnRef>
-            <a:fillRef idx="0">
-              <a:schemeClr val="accent1"/>
-            </a:fillRef>
-            <a:effectRef idx="0">
-              <a:schemeClr val="accent1"/>
-            </a:effectRef>
-            <a:fontRef idx="minor">
-              <a:schemeClr val="tx1"/>
-            </a:fontRef>
-          </p:style>
-        </p:cxnSp>
-        <p:sp>
-          <p:nvSpPr>
-            <p:cNvPr id="14" name="Oval 13">
-              <a:extLst>
-                <a:ext uri="{FF2B5EF4-FFF2-40B4-BE49-F238E27FC236}">
-                  <a16:creationId xmlns:a16="http://schemas.microsoft.com/office/drawing/2014/main" id="{4450A7CC-1913-CA77-2A9D-3E4AB5920017}"/>
-                </a:ext>
-              </a:extLst>
-            </p:cNvPr>
-            <p:cNvSpPr/>
-            <p:nvPr/>
-          </p:nvSpPr>
-          <p:spPr>
-            <a:xfrm>
-              <a:off x="1762911" y="2879190"/>
-              <a:ext cx="994725" cy="1047378"/>
-            </a:xfrm>
-            <a:prstGeom prst="ellipse">
-              <a:avLst/>
-            </a:prstGeom>
-            <a:solidFill>
-              <a:schemeClr val="bg1"/>
-            </a:solidFill>
-            <a:ln w="57150">
-              <a:solidFill>
-                <a:schemeClr val="tx1"/>
-              </a:solidFill>
-            </a:ln>
-          </p:spPr>
-          <p:style>
-            <a:lnRef idx="2">
-              <a:schemeClr val="accent1">
-                <a:shade val="50000"/>
-              </a:schemeClr>
-            </a:lnRef>
-            <a:fillRef idx="1">
-              <a:schemeClr val="accent1"/>
-            </a:fillRef>
-            <a:effectRef idx="0">
-              <a:schemeClr val="accent1"/>
-            </a:effectRef>
-            <a:fontRef idx="minor">
-              <a:schemeClr val="lt1"/>
-            </a:fontRef>
-          </p:style>
-          <p:txBody>
-            <a:bodyPr rtlCol="0" anchor="ctr"/>
-            <a:lstStyle/>
-            <a:p>
-              <a:pPr algn="ctr"/>
-              <a:r>
-                <a:rPr lang="en-US" sz="3600" noProof="0" dirty="0">
-                  <a:solidFill>
-                    <a:schemeClr val="tx1"/>
-                  </a:solidFill>
-                </a:rPr>
-                <a:t>A</a:t>
-              </a:r>
-            </a:p>
-          </p:txBody>
-        </p:sp>
-        <p:sp>
-          <p:nvSpPr>
-            <p:cNvPr id="15" name="Oval 14">
-              <a:extLst>
-                <a:ext uri="{FF2B5EF4-FFF2-40B4-BE49-F238E27FC236}">
-                  <a16:creationId xmlns:a16="http://schemas.microsoft.com/office/drawing/2014/main" id="{F9E9067C-3607-0080-3501-671586D55684}"/>
-                </a:ext>
-              </a:extLst>
-            </p:cNvPr>
-            <p:cNvSpPr/>
-            <p:nvPr/>
-          </p:nvSpPr>
-          <p:spPr>
-            <a:xfrm>
-              <a:off x="4310444" y="1651683"/>
-              <a:ext cx="994725" cy="1047378"/>
-            </a:xfrm>
-            <a:prstGeom prst="ellipse">
-              <a:avLst/>
-            </a:prstGeom>
-            <a:solidFill>
-              <a:schemeClr val="bg1"/>
-            </a:solidFill>
-            <a:ln w="57150">
-              <a:solidFill>
-                <a:schemeClr val="tx1"/>
-              </a:solidFill>
-            </a:ln>
-          </p:spPr>
-          <p:style>
-            <a:lnRef idx="2">
-              <a:schemeClr val="accent1">
-                <a:shade val="50000"/>
-              </a:schemeClr>
-            </a:lnRef>
-            <a:fillRef idx="1">
-              <a:schemeClr val="accent1"/>
-            </a:fillRef>
-            <a:effectRef idx="0">
-              <a:schemeClr val="accent1"/>
-            </a:effectRef>
-            <a:fontRef idx="minor">
-              <a:schemeClr val="lt1"/>
-            </a:fontRef>
-          </p:style>
-          <p:txBody>
-            <a:bodyPr rtlCol="0" anchor="ctr"/>
-            <a:lstStyle/>
-            <a:p>
-              <a:pPr algn="ctr"/>
-              <a:r>
-                <a:rPr lang="en-US" sz="3600" noProof="0" dirty="0">
-                  <a:solidFill>
-                    <a:schemeClr val="tx1"/>
-                  </a:solidFill>
-                </a:rPr>
-                <a:t>B</a:t>
-              </a:r>
-            </a:p>
-          </p:txBody>
-        </p:sp>
-        <p:sp>
-          <p:nvSpPr>
-            <p:cNvPr id="16" name="Oval 15">
-              <a:extLst>
-                <a:ext uri="{FF2B5EF4-FFF2-40B4-BE49-F238E27FC236}">
-                  <a16:creationId xmlns:a16="http://schemas.microsoft.com/office/drawing/2014/main" id="{279B9CF3-5C34-DB5C-1967-564D193982F1}"/>
-                </a:ext>
-              </a:extLst>
-            </p:cNvPr>
-            <p:cNvSpPr/>
-            <p:nvPr/>
-          </p:nvSpPr>
-          <p:spPr>
-            <a:xfrm>
-              <a:off x="7323945" y="1651683"/>
-              <a:ext cx="994725" cy="1047378"/>
-            </a:xfrm>
-            <a:prstGeom prst="ellipse">
-              <a:avLst/>
-            </a:prstGeom>
-            <a:solidFill>
-              <a:schemeClr val="bg1"/>
-            </a:solidFill>
-            <a:ln w="57150">
-              <a:solidFill>
-                <a:schemeClr val="tx1"/>
-              </a:solidFill>
-            </a:ln>
-          </p:spPr>
-          <p:style>
-            <a:lnRef idx="2">
-              <a:schemeClr val="accent1">
-                <a:shade val="50000"/>
-              </a:schemeClr>
-            </a:lnRef>
-            <a:fillRef idx="1">
-              <a:schemeClr val="accent1"/>
-            </a:fillRef>
-            <a:effectRef idx="0">
-              <a:schemeClr val="accent1"/>
-            </a:effectRef>
-            <a:fontRef idx="minor">
-              <a:schemeClr val="lt1"/>
-            </a:fontRef>
-          </p:style>
-          <p:txBody>
-            <a:bodyPr rtlCol="0" anchor="ctr"/>
-            <a:lstStyle/>
-            <a:p>
-              <a:pPr algn="ctr"/>
-              <a:r>
-                <a:rPr lang="en-US" sz="3600" noProof="0" dirty="0">
-                  <a:solidFill>
-                    <a:schemeClr val="tx1"/>
-                  </a:solidFill>
-                </a:rPr>
-                <a:t>D</a:t>
-              </a:r>
-            </a:p>
-          </p:txBody>
-        </p:sp>
-        <p:sp>
-          <p:nvSpPr>
-            <p:cNvPr id="17" name="Oval 16">
-              <a:extLst>
-                <a:ext uri="{FF2B5EF4-FFF2-40B4-BE49-F238E27FC236}">
-                  <a16:creationId xmlns:a16="http://schemas.microsoft.com/office/drawing/2014/main" id="{E5707333-CDDE-2684-8B37-5894509525B6}"/>
-                </a:ext>
-              </a:extLst>
-            </p:cNvPr>
-            <p:cNvSpPr/>
-            <p:nvPr/>
-          </p:nvSpPr>
-          <p:spPr>
-            <a:xfrm>
-              <a:off x="4310444" y="4198014"/>
-              <a:ext cx="994725" cy="1047378"/>
-            </a:xfrm>
-            <a:prstGeom prst="ellipse">
-              <a:avLst/>
-            </a:prstGeom>
-            <a:solidFill>
-              <a:schemeClr val="bg1"/>
-            </a:solidFill>
-            <a:ln w="57150">
-              <a:solidFill>
-                <a:schemeClr val="tx1"/>
-              </a:solidFill>
-            </a:ln>
-          </p:spPr>
-          <p:style>
-            <a:lnRef idx="2">
-              <a:schemeClr val="accent1">
-                <a:shade val="50000"/>
-              </a:schemeClr>
-            </a:lnRef>
-            <a:fillRef idx="1">
-              <a:schemeClr val="accent1"/>
-            </a:fillRef>
-            <a:effectRef idx="0">
-              <a:schemeClr val="accent1"/>
-            </a:effectRef>
-            <a:fontRef idx="minor">
-              <a:schemeClr val="lt1"/>
-            </a:fontRef>
-          </p:style>
-          <p:txBody>
-            <a:bodyPr rtlCol="0" anchor="ctr"/>
-            <a:lstStyle/>
-            <a:p>
-              <a:pPr algn="ctr"/>
-              <a:r>
-                <a:rPr lang="en-US" sz="3600" noProof="0" dirty="0">
-                  <a:solidFill>
-                    <a:schemeClr val="tx1"/>
-                  </a:solidFill>
-                </a:rPr>
-                <a:t>C</a:t>
-              </a:r>
-            </a:p>
-          </p:txBody>
-        </p:sp>
-        <p:sp>
-          <p:nvSpPr>
-            <p:cNvPr id="18" name="Oval 17">
-              <a:extLst>
-                <a:ext uri="{FF2B5EF4-FFF2-40B4-BE49-F238E27FC236}">
-                  <a16:creationId xmlns:a16="http://schemas.microsoft.com/office/drawing/2014/main" id="{0C3A53FE-8559-176A-1DAC-5C558AEE10DB}"/>
-                </a:ext>
-              </a:extLst>
-            </p:cNvPr>
-            <p:cNvSpPr/>
-            <p:nvPr/>
-          </p:nvSpPr>
-          <p:spPr>
-            <a:xfrm>
-              <a:off x="7323945" y="4198014"/>
-              <a:ext cx="994725" cy="1047378"/>
-            </a:xfrm>
-            <a:prstGeom prst="ellipse">
-              <a:avLst/>
-            </a:prstGeom>
-            <a:solidFill>
-              <a:schemeClr val="bg1"/>
-            </a:solidFill>
-            <a:ln w="57150">
-              <a:solidFill>
-                <a:schemeClr val="tx1"/>
-              </a:solidFill>
-            </a:ln>
-          </p:spPr>
-          <p:style>
-            <a:lnRef idx="2">
-              <a:schemeClr val="accent1">
-                <a:shade val="50000"/>
-              </a:schemeClr>
-            </a:lnRef>
-            <a:fillRef idx="1">
-              <a:schemeClr val="accent1"/>
-            </a:fillRef>
-            <a:effectRef idx="0">
-              <a:schemeClr val="accent1"/>
-            </a:effectRef>
-            <a:fontRef idx="minor">
-              <a:schemeClr val="lt1"/>
-            </a:fontRef>
-          </p:style>
-          <p:txBody>
-            <a:bodyPr rtlCol="0" anchor="ctr"/>
-            <a:lstStyle/>
-            <a:p>
-              <a:pPr algn="ctr"/>
-              <a:r>
-                <a:rPr lang="en-US" sz="3600" noProof="0" dirty="0">
-                  <a:solidFill>
-                    <a:schemeClr val="tx1"/>
-                  </a:solidFill>
-                </a:rPr>
-                <a:t>E</a:t>
-              </a:r>
-            </a:p>
-          </p:txBody>
-        </p:sp>
-        <p:sp>
-          <p:nvSpPr>
-            <p:cNvPr id="19" name="Oval 18">
-              <a:extLst>
-                <a:ext uri="{FF2B5EF4-FFF2-40B4-BE49-F238E27FC236}">
-                  <a16:creationId xmlns:a16="http://schemas.microsoft.com/office/drawing/2014/main" id="{9A59F3BA-3714-4647-33D7-0C0D3382656F}"/>
-                </a:ext>
-              </a:extLst>
-            </p:cNvPr>
-            <p:cNvSpPr/>
-            <p:nvPr/>
-          </p:nvSpPr>
-          <p:spPr>
-            <a:xfrm>
-              <a:off x="10024374" y="2879190"/>
-              <a:ext cx="994725" cy="1047378"/>
-            </a:xfrm>
-            <a:prstGeom prst="ellipse">
-              <a:avLst/>
-            </a:prstGeom>
-            <a:solidFill>
-              <a:schemeClr val="bg1"/>
-            </a:solidFill>
-            <a:ln w="57150">
-              <a:solidFill>
-                <a:schemeClr val="tx1"/>
-              </a:solidFill>
-            </a:ln>
-          </p:spPr>
-          <p:style>
-            <a:lnRef idx="2">
-              <a:schemeClr val="accent1">
-                <a:shade val="50000"/>
-              </a:schemeClr>
-            </a:lnRef>
-            <a:fillRef idx="1">
-              <a:schemeClr val="accent1"/>
-            </a:fillRef>
-            <a:effectRef idx="0">
-              <a:schemeClr val="accent1"/>
-            </a:effectRef>
-            <a:fontRef idx="minor">
-              <a:schemeClr val="lt1"/>
-            </a:fontRef>
-          </p:style>
-          <p:txBody>
-            <a:bodyPr rtlCol="0" anchor="ctr"/>
-            <a:lstStyle/>
-            <a:p>
-              <a:pPr algn="ctr"/>
-              <a:r>
-                <a:rPr lang="en-US" sz="3600" noProof="0" dirty="0">
-                  <a:solidFill>
-                    <a:schemeClr val="tx1"/>
-                  </a:solidFill>
-                </a:rPr>
-                <a:t>F</a:t>
-              </a:r>
-            </a:p>
-          </p:txBody>
-        </p:sp>
-        <p:grpSp>
-          <p:nvGrpSpPr>
-            <p:cNvPr id="20" name="Group 19">
-              <a:extLst>
-                <a:ext uri="{FF2B5EF4-FFF2-40B4-BE49-F238E27FC236}">
-                  <a16:creationId xmlns:a16="http://schemas.microsoft.com/office/drawing/2014/main" id="{D508DE74-2617-AA88-4645-2D44F411E68E}"/>
-                </a:ext>
-              </a:extLst>
-            </p:cNvPr>
-            <p:cNvGrpSpPr/>
-            <p:nvPr/>
-          </p:nvGrpSpPr>
-          <p:grpSpPr>
-            <a:xfrm>
-              <a:off x="3279207" y="1691208"/>
-              <a:ext cx="6465012" cy="3486113"/>
-              <a:chOff x="2954901" y="2640921"/>
-              <a:chExt cx="4679489" cy="2396461"/>
-            </a:xfrm>
-          </p:grpSpPr>
-          <p:sp>
-            <p:nvSpPr>
-              <p:cNvPr id="32" name="TextBox 31">
-                <a:extLst>
-                  <a:ext uri="{FF2B5EF4-FFF2-40B4-BE49-F238E27FC236}">
-                    <a16:creationId xmlns:a16="http://schemas.microsoft.com/office/drawing/2014/main" id="{46DDC04F-0D73-E024-8DB1-162F66FDB77C}"/>
-                  </a:ext>
-                </a:extLst>
-              </p:cNvPr>
-              <p:cNvSpPr txBox="1"/>
-              <p:nvPr/>
-            </p:nvSpPr>
-            <p:spPr>
-              <a:xfrm>
-                <a:off x="2977945" y="4000516"/>
-                <a:ext cx="500932" cy="317363"/>
-              </a:xfrm>
-              <a:prstGeom prst="rect">
-                <a:avLst/>
-              </a:prstGeom>
-              <a:noFill/>
-            </p:spPr>
-            <p:txBody>
-              <a:bodyPr wrap="square" rtlCol="0">
-                <a:spAutoFit/>
-              </a:bodyPr>
-              <a:lstStyle/>
-              <a:p>
-                <a:r>
-                  <a:rPr lang="en-US" sz="2400" i="1" noProof="0" dirty="0">
-                    <a:solidFill>
-                      <a:srgbClr val="C00000"/>
-                    </a:solidFill>
-                  </a:rPr>
-                  <a:t>x</a:t>
-                </a:r>
-                <a:r>
-                  <a:rPr lang="en-US" sz="2400" baseline="-25000" noProof="0" dirty="0">
-                    <a:solidFill>
-                      <a:srgbClr val="C00000"/>
-                    </a:solidFill>
-                  </a:rPr>
-                  <a:t>0</a:t>
-                </a:r>
-              </a:p>
-            </p:txBody>
-          </p:sp>
-          <p:sp>
-            <p:nvSpPr>
-              <p:cNvPr id="33" name="TextBox 32">
-                <a:extLst>
-                  <a:ext uri="{FF2B5EF4-FFF2-40B4-BE49-F238E27FC236}">
-                    <a16:creationId xmlns:a16="http://schemas.microsoft.com/office/drawing/2014/main" id="{2C4B960E-D2CB-16A4-E984-9ACE4A0A0D8D}"/>
-                  </a:ext>
-                </a:extLst>
-              </p:cNvPr>
-              <p:cNvSpPr txBox="1"/>
-              <p:nvPr/>
-            </p:nvSpPr>
-            <p:spPr>
-              <a:xfrm>
-                <a:off x="2954901" y="3373663"/>
-                <a:ext cx="500932" cy="317363"/>
-              </a:xfrm>
-              <a:prstGeom prst="rect">
-                <a:avLst/>
-              </a:prstGeom>
-              <a:noFill/>
-            </p:spPr>
-            <p:txBody>
-              <a:bodyPr wrap="square" rtlCol="0">
-                <a:spAutoFit/>
-              </a:bodyPr>
-              <a:lstStyle/>
-              <a:p>
-                <a:r>
-                  <a:rPr lang="en-US" sz="2400" i="1" noProof="0" dirty="0">
-                    <a:solidFill>
-                      <a:srgbClr val="C00000"/>
-                    </a:solidFill>
-                  </a:rPr>
-                  <a:t>x</a:t>
-                </a:r>
-                <a:r>
-                  <a:rPr lang="en-US" sz="2400" baseline="-25000" noProof="0" dirty="0">
-                    <a:solidFill>
-                      <a:srgbClr val="C00000"/>
-                    </a:solidFill>
-                  </a:rPr>
-                  <a:t>1</a:t>
-                </a:r>
-              </a:p>
-            </p:txBody>
-          </p:sp>
-          <p:sp>
-            <p:nvSpPr>
-              <p:cNvPr id="34" name="TextBox 33">
-                <a:extLst>
-                  <a:ext uri="{FF2B5EF4-FFF2-40B4-BE49-F238E27FC236}">
-                    <a16:creationId xmlns:a16="http://schemas.microsoft.com/office/drawing/2014/main" id="{B18AD135-C3E9-13FA-19BD-AF402C6899CB}"/>
-                  </a:ext>
-                </a:extLst>
-              </p:cNvPr>
-              <p:cNvSpPr txBox="1"/>
-              <p:nvPr/>
-            </p:nvSpPr>
-            <p:spPr>
-              <a:xfrm>
-                <a:off x="4912086" y="4720019"/>
-                <a:ext cx="500932" cy="317363"/>
-              </a:xfrm>
-              <a:prstGeom prst="rect">
-                <a:avLst/>
-              </a:prstGeom>
-              <a:noFill/>
-            </p:spPr>
-            <p:txBody>
-              <a:bodyPr wrap="square" rtlCol="0">
-                <a:spAutoFit/>
-              </a:bodyPr>
-              <a:lstStyle/>
-              <a:p>
-                <a:r>
-                  <a:rPr lang="en-US" sz="2400" i="1" noProof="0" dirty="0">
-                    <a:solidFill>
-                      <a:srgbClr val="C00000"/>
-                    </a:solidFill>
-                  </a:rPr>
-                  <a:t>x</a:t>
-                </a:r>
-                <a:r>
-                  <a:rPr lang="en-US" sz="2400" baseline="-25000" noProof="0" dirty="0">
-                    <a:solidFill>
-                      <a:srgbClr val="C00000"/>
-                    </a:solidFill>
-                  </a:rPr>
-                  <a:t>2</a:t>
-                </a:r>
-              </a:p>
-            </p:txBody>
-          </p:sp>
-          <p:sp>
-            <p:nvSpPr>
-              <p:cNvPr id="35" name="TextBox 34">
-                <a:extLst>
-                  <a:ext uri="{FF2B5EF4-FFF2-40B4-BE49-F238E27FC236}">
-                    <a16:creationId xmlns:a16="http://schemas.microsoft.com/office/drawing/2014/main" id="{D0E85865-4ADC-012E-E9D8-B0F5D586AF0B}"/>
-                  </a:ext>
-                </a:extLst>
-              </p:cNvPr>
-              <p:cNvSpPr txBox="1"/>
-              <p:nvPr/>
-            </p:nvSpPr>
-            <p:spPr>
-              <a:xfrm>
-                <a:off x="4889589" y="2640921"/>
-                <a:ext cx="500932" cy="317363"/>
-              </a:xfrm>
-              <a:prstGeom prst="rect">
-                <a:avLst/>
-              </a:prstGeom>
-              <a:noFill/>
-            </p:spPr>
-            <p:txBody>
-              <a:bodyPr wrap="square" rtlCol="0">
-                <a:spAutoFit/>
-              </a:bodyPr>
-              <a:lstStyle/>
-              <a:p>
-                <a:r>
-                  <a:rPr lang="en-US" sz="2400" i="1" noProof="0" dirty="0">
-                    <a:solidFill>
-                      <a:srgbClr val="C00000"/>
-                    </a:solidFill>
-                  </a:rPr>
-                  <a:t>x</a:t>
-                </a:r>
-                <a:r>
-                  <a:rPr lang="en-US" sz="2400" baseline="-25000" noProof="0" dirty="0">
-                    <a:solidFill>
-                      <a:srgbClr val="C00000"/>
-                    </a:solidFill>
-                  </a:rPr>
-                  <a:t>5</a:t>
-                </a:r>
-              </a:p>
-            </p:txBody>
-          </p:sp>
-          <p:sp>
-            <p:nvSpPr>
-              <p:cNvPr id="36" name="TextBox 35">
-                <a:extLst>
-                  <a:ext uri="{FF2B5EF4-FFF2-40B4-BE49-F238E27FC236}">
-                    <a16:creationId xmlns:a16="http://schemas.microsoft.com/office/drawing/2014/main" id="{B8E60450-2D1A-44CE-94C9-78D653F6E96E}"/>
-                  </a:ext>
-                </a:extLst>
-              </p:cNvPr>
-              <p:cNvSpPr txBox="1"/>
-              <p:nvPr/>
-            </p:nvSpPr>
-            <p:spPr>
-              <a:xfrm>
-                <a:off x="4702917" y="3206364"/>
-                <a:ext cx="500932" cy="317363"/>
-              </a:xfrm>
-              <a:prstGeom prst="rect">
-                <a:avLst/>
-              </a:prstGeom>
-              <a:noFill/>
-            </p:spPr>
-            <p:txBody>
-              <a:bodyPr wrap="square" rtlCol="0">
-                <a:spAutoFit/>
-              </a:bodyPr>
-              <a:lstStyle/>
-              <a:p>
-                <a:r>
-                  <a:rPr lang="en-US" sz="2400" i="1" noProof="0" dirty="0">
-                    <a:solidFill>
-                      <a:srgbClr val="C00000"/>
-                    </a:solidFill>
-                  </a:rPr>
-                  <a:t>x</a:t>
-                </a:r>
-                <a:r>
-                  <a:rPr lang="en-US" sz="2400" baseline="-25000" noProof="0" dirty="0">
-                    <a:solidFill>
-                      <a:srgbClr val="C00000"/>
-                    </a:solidFill>
-                  </a:rPr>
-                  <a:t>4</a:t>
-                </a:r>
-              </a:p>
-            </p:txBody>
-          </p:sp>
-          <p:sp>
-            <p:nvSpPr>
-              <p:cNvPr id="37" name="TextBox 36">
-                <a:extLst>
-                  <a:ext uri="{FF2B5EF4-FFF2-40B4-BE49-F238E27FC236}">
-                    <a16:creationId xmlns:a16="http://schemas.microsoft.com/office/drawing/2014/main" id="{80436E68-147F-4A70-0DFD-612E34A11AD7}"/>
-                  </a:ext>
-                </a:extLst>
-              </p:cNvPr>
-              <p:cNvSpPr txBox="1"/>
-              <p:nvPr/>
-            </p:nvSpPr>
-            <p:spPr>
-              <a:xfrm>
-                <a:off x="4661619" y="4129559"/>
-                <a:ext cx="500932" cy="317363"/>
-              </a:xfrm>
-              <a:prstGeom prst="rect">
-                <a:avLst/>
-              </a:prstGeom>
-              <a:noFill/>
-            </p:spPr>
-            <p:txBody>
-              <a:bodyPr wrap="square" rtlCol="0">
-                <a:spAutoFit/>
-              </a:bodyPr>
-              <a:lstStyle/>
-              <a:p>
-                <a:r>
-                  <a:rPr lang="en-US" sz="2400" i="1" noProof="0" dirty="0">
-                    <a:solidFill>
-                      <a:srgbClr val="C00000"/>
-                    </a:solidFill>
-                  </a:rPr>
-                  <a:t>x</a:t>
-                </a:r>
-                <a:r>
-                  <a:rPr lang="en-US" sz="2400" baseline="-25000" noProof="0" dirty="0">
-                    <a:solidFill>
-                      <a:srgbClr val="C00000"/>
-                    </a:solidFill>
-                  </a:rPr>
-                  <a:t>3</a:t>
-                </a:r>
-              </a:p>
-            </p:txBody>
-          </p:sp>
-          <p:sp>
-            <p:nvSpPr>
-              <p:cNvPr id="38" name="TextBox 37">
-                <a:extLst>
-                  <a:ext uri="{FF2B5EF4-FFF2-40B4-BE49-F238E27FC236}">
-                    <a16:creationId xmlns:a16="http://schemas.microsoft.com/office/drawing/2014/main" id="{059B0825-61FC-7059-6B18-C095C8393D89}"/>
-                  </a:ext>
-                </a:extLst>
-              </p:cNvPr>
-              <p:cNvSpPr txBox="1"/>
-              <p:nvPr/>
-            </p:nvSpPr>
-            <p:spPr>
-              <a:xfrm>
-                <a:off x="6253607" y="3716128"/>
-                <a:ext cx="500932" cy="317363"/>
-              </a:xfrm>
-              <a:prstGeom prst="rect">
-                <a:avLst/>
-              </a:prstGeom>
-              <a:noFill/>
-            </p:spPr>
-            <p:txBody>
-              <a:bodyPr wrap="square" rtlCol="0">
-                <a:spAutoFit/>
-              </a:bodyPr>
-              <a:lstStyle/>
-              <a:p>
-                <a:r>
-                  <a:rPr lang="en-US" sz="2400" i="1" noProof="0" dirty="0">
-                    <a:solidFill>
-                      <a:srgbClr val="C00000"/>
-                    </a:solidFill>
-                  </a:rPr>
-                  <a:t>x</a:t>
-                </a:r>
-                <a:r>
-                  <a:rPr lang="en-US" sz="2400" baseline="-25000" noProof="0" dirty="0">
-                    <a:solidFill>
-                      <a:srgbClr val="C00000"/>
-                    </a:solidFill>
-                  </a:rPr>
-                  <a:t>6</a:t>
-                </a:r>
-              </a:p>
-            </p:txBody>
-          </p:sp>
-          <p:sp>
-            <p:nvSpPr>
-              <p:cNvPr id="39" name="TextBox 38">
-                <a:extLst>
-                  <a:ext uri="{FF2B5EF4-FFF2-40B4-BE49-F238E27FC236}">
-                    <a16:creationId xmlns:a16="http://schemas.microsoft.com/office/drawing/2014/main" id="{EDCA9714-F190-B949-1761-D1F7B52F0ABE}"/>
-                  </a:ext>
-                </a:extLst>
-              </p:cNvPr>
-              <p:cNvSpPr txBox="1"/>
-              <p:nvPr/>
-            </p:nvSpPr>
-            <p:spPr>
-              <a:xfrm>
-                <a:off x="7085688" y="2941900"/>
-                <a:ext cx="500932" cy="317363"/>
-              </a:xfrm>
-              <a:prstGeom prst="rect">
-                <a:avLst/>
-              </a:prstGeom>
-              <a:noFill/>
-            </p:spPr>
-            <p:txBody>
-              <a:bodyPr wrap="square" rtlCol="0">
-                <a:spAutoFit/>
-              </a:bodyPr>
-              <a:lstStyle/>
-              <a:p>
-                <a:r>
-                  <a:rPr lang="en-US" sz="2400" i="1" noProof="0" dirty="0">
-                    <a:solidFill>
-                      <a:srgbClr val="C00000"/>
-                    </a:solidFill>
-                  </a:rPr>
-                  <a:t>x</a:t>
-                </a:r>
-                <a:r>
-                  <a:rPr lang="en-US" sz="2400" baseline="-25000" noProof="0" dirty="0">
-                    <a:solidFill>
-                      <a:srgbClr val="C00000"/>
-                    </a:solidFill>
-                  </a:rPr>
-                  <a:t>8</a:t>
-                </a:r>
-              </a:p>
-            </p:txBody>
-          </p:sp>
-          <p:sp>
-            <p:nvSpPr>
-              <p:cNvPr id="40" name="TextBox 39">
-                <a:extLst>
-                  <a:ext uri="{FF2B5EF4-FFF2-40B4-BE49-F238E27FC236}">
-                    <a16:creationId xmlns:a16="http://schemas.microsoft.com/office/drawing/2014/main" id="{C353AD7A-A1C0-CEC4-0FF8-CF22C94BFBFC}"/>
-                  </a:ext>
-                </a:extLst>
-              </p:cNvPr>
-              <p:cNvSpPr txBox="1"/>
-              <p:nvPr/>
-            </p:nvSpPr>
-            <p:spPr>
-              <a:xfrm>
-                <a:off x="7133458" y="4315419"/>
-                <a:ext cx="500932" cy="317363"/>
-              </a:xfrm>
-              <a:prstGeom prst="rect">
-                <a:avLst/>
-              </a:prstGeom>
-              <a:noFill/>
-            </p:spPr>
-            <p:txBody>
-              <a:bodyPr wrap="square" rtlCol="0">
-                <a:spAutoFit/>
-              </a:bodyPr>
-              <a:lstStyle/>
-              <a:p>
-                <a:r>
-                  <a:rPr lang="en-US" sz="2400" i="1" noProof="0" dirty="0">
-                    <a:solidFill>
-                      <a:srgbClr val="C00000"/>
-                    </a:solidFill>
-                  </a:rPr>
-                  <a:t>x</a:t>
-                </a:r>
-                <a:r>
-                  <a:rPr lang="en-US" sz="2400" baseline="-25000" noProof="0" dirty="0">
-                    <a:solidFill>
-                      <a:srgbClr val="C00000"/>
-                    </a:solidFill>
-                  </a:rPr>
-                  <a:t>7</a:t>
-                </a:r>
-              </a:p>
-            </p:txBody>
-          </p:sp>
-        </p:grpSp>
-        <p:sp>
-          <p:nvSpPr>
-            <p:cNvPr id="21" name="TextBox 20">
-              <a:extLst>
-                <a:ext uri="{FF2B5EF4-FFF2-40B4-BE49-F238E27FC236}">
-                  <a16:creationId xmlns:a16="http://schemas.microsoft.com/office/drawing/2014/main" id="{2A5E7A64-1498-7C36-8E17-18D49260DFA5}"/>
-                </a:ext>
-              </a:extLst>
-            </p:cNvPr>
-            <p:cNvSpPr txBox="1"/>
-            <p:nvPr/>
-          </p:nvSpPr>
-          <p:spPr>
-            <a:xfrm>
-              <a:off x="3106835" y="2373976"/>
-              <a:ext cx="692069" cy="461665"/>
-            </a:xfrm>
-            <a:prstGeom prst="rect">
-              <a:avLst/>
-            </a:prstGeom>
-            <a:noFill/>
-          </p:spPr>
-          <p:txBody>
-            <a:bodyPr wrap="square" rtlCol="0">
-              <a:spAutoFit/>
-            </a:bodyPr>
-            <a:lstStyle/>
-            <a:p>
-              <a:r>
-                <a:rPr lang="en-US" sz="2400" noProof="0" dirty="0">
-                  <a:solidFill>
-                    <a:schemeClr val="accent1">
-                      <a:lumMod val="50000"/>
-                    </a:schemeClr>
-                  </a:solidFill>
-                </a:rPr>
-                <a:t>3</a:t>
-              </a:r>
-            </a:p>
-          </p:txBody>
-        </p:sp>
-        <p:sp>
-          <p:nvSpPr>
-            <p:cNvPr id="22" name="TextBox 21">
-              <a:extLst>
-                <a:ext uri="{FF2B5EF4-FFF2-40B4-BE49-F238E27FC236}">
-                  <a16:creationId xmlns:a16="http://schemas.microsoft.com/office/drawing/2014/main" id="{2499013F-0C78-6139-0A24-DABD3FDBC2E6}"/>
-                </a:ext>
-              </a:extLst>
-            </p:cNvPr>
-            <p:cNvSpPr txBox="1"/>
-            <p:nvPr/>
-          </p:nvSpPr>
-          <p:spPr>
-            <a:xfrm>
-              <a:off x="3115024" y="4153486"/>
-              <a:ext cx="692069" cy="461665"/>
-            </a:xfrm>
-            <a:prstGeom prst="rect">
-              <a:avLst/>
-            </a:prstGeom>
-            <a:noFill/>
-          </p:spPr>
-          <p:txBody>
-            <a:bodyPr wrap="square" rtlCol="0">
-              <a:spAutoFit/>
-            </a:bodyPr>
-            <a:lstStyle/>
-            <a:p>
-              <a:r>
-                <a:rPr lang="en-US" sz="2400" noProof="0" dirty="0">
-                  <a:solidFill>
-                    <a:schemeClr val="accent1">
-                      <a:lumMod val="50000"/>
-                    </a:schemeClr>
-                  </a:solidFill>
-                </a:rPr>
-                <a:t>4</a:t>
-              </a:r>
-            </a:p>
-          </p:txBody>
-        </p:sp>
-        <p:sp>
-          <p:nvSpPr>
-            <p:cNvPr id="23" name="TextBox 22">
-              <a:extLst>
-                <a:ext uri="{FF2B5EF4-FFF2-40B4-BE49-F238E27FC236}">
-                  <a16:creationId xmlns:a16="http://schemas.microsoft.com/office/drawing/2014/main" id="{C42104DF-C651-8873-33D5-98D021F6E0CE}"/>
-                </a:ext>
-              </a:extLst>
-            </p:cNvPr>
-            <p:cNvSpPr txBox="1"/>
-            <p:nvPr/>
-          </p:nvSpPr>
-          <p:spPr>
-            <a:xfrm>
-              <a:off x="6005038" y="4220841"/>
-              <a:ext cx="692069" cy="461665"/>
-            </a:xfrm>
-            <a:prstGeom prst="rect">
-              <a:avLst/>
-            </a:prstGeom>
-            <a:noFill/>
-          </p:spPr>
-          <p:txBody>
-            <a:bodyPr wrap="square" rtlCol="0">
-              <a:spAutoFit/>
-            </a:bodyPr>
-            <a:lstStyle/>
-            <a:p>
-              <a:r>
-                <a:rPr lang="en-US" sz="2400" noProof="0" dirty="0">
-                  <a:solidFill>
-                    <a:schemeClr val="accent1">
-                      <a:lumMod val="50000"/>
-                    </a:schemeClr>
-                  </a:solidFill>
-                </a:rPr>
-                <a:t>1</a:t>
-              </a:r>
-            </a:p>
-          </p:txBody>
-        </p:sp>
-        <p:sp>
-          <p:nvSpPr>
-            <p:cNvPr id="24" name="TextBox 23">
-              <a:extLst>
-                <a:ext uri="{FF2B5EF4-FFF2-40B4-BE49-F238E27FC236}">
-                  <a16:creationId xmlns:a16="http://schemas.microsoft.com/office/drawing/2014/main" id="{3D5A51FD-16E9-376C-10BF-AAD202F9EAFC}"/>
-                </a:ext>
-              </a:extLst>
-            </p:cNvPr>
-            <p:cNvSpPr txBox="1"/>
-            <p:nvPr/>
-          </p:nvSpPr>
-          <p:spPr>
-            <a:xfrm>
-              <a:off x="5991520" y="2133965"/>
-              <a:ext cx="692069" cy="461665"/>
-            </a:xfrm>
-            <a:prstGeom prst="rect">
-              <a:avLst/>
-            </a:prstGeom>
-            <a:noFill/>
-          </p:spPr>
-          <p:txBody>
-            <a:bodyPr wrap="square" rtlCol="0">
-              <a:spAutoFit/>
-            </a:bodyPr>
-            <a:lstStyle/>
-            <a:p>
-              <a:r>
-                <a:rPr lang="en-US" sz="2400" noProof="0" dirty="0">
-                  <a:solidFill>
-                    <a:schemeClr val="accent1">
-                      <a:lumMod val="50000"/>
-                    </a:schemeClr>
-                  </a:solidFill>
-                </a:rPr>
-                <a:t>1</a:t>
-              </a:r>
-            </a:p>
-          </p:txBody>
-        </p:sp>
-        <p:sp>
-          <p:nvSpPr>
-            <p:cNvPr id="25" name="TextBox 24">
-              <a:extLst>
-                <a:ext uri="{FF2B5EF4-FFF2-40B4-BE49-F238E27FC236}">
-                  <a16:creationId xmlns:a16="http://schemas.microsoft.com/office/drawing/2014/main" id="{D79F5E97-7721-9B11-0366-23048C21794F}"/>
-                </a:ext>
-              </a:extLst>
-            </p:cNvPr>
-            <p:cNvSpPr txBox="1"/>
-            <p:nvPr/>
-          </p:nvSpPr>
-          <p:spPr>
-            <a:xfrm>
-              <a:off x="8496812" y="2653217"/>
-              <a:ext cx="692069" cy="461665"/>
-            </a:xfrm>
-            <a:prstGeom prst="rect">
-              <a:avLst/>
-            </a:prstGeom>
-            <a:noFill/>
-          </p:spPr>
-          <p:txBody>
-            <a:bodyPr wrap="square" rtlCol="0">
-              <a:spAutoFit/>
-            </a:bodyPr>
-            <a:lstStyle/>
-            <a:p>
-              <a:pPr algn="r"/>
-              <a:r>
-                <a:rPr lang="en-US" sz="2400" noProof="0" dirty="0">
-                  <a:solidFill>
-                    <a:schemeClr val="accent1">
-                      <a:lumMod val="50000"/>
-                    </a:schemeClr>
-                  </a:solidFill>
-                </a:rPr>
-                <a:t>5</a:t>
-              </a:r>
-            </a:p>
-          </p:txBody>
-        </p:sp>
-        <p:sp>
-          <p:nvSpPr>
-            <p:cNvPr id="26" name="TextBox 25">
-              <a:extLst>
-                <a:ext uri="{FF2B5EF4-FFF2-40B4-BE49-F238E27FC236}">
-                  <a16:creationId xmlns:a16="http://schemas.microsoft.com/office/drawing/2014/main" id="{400853D2-224B-3FA9-36DD-0E15BA12C309}"/>
-                </a:ext>
-              </a:extLst>
-            </p:cNvPr>
-            <p:cNvSpPr txBox="1"/>
-            <p:nvPr/>
-          </p:nvSpPr>
-          <p:spPr>
-            <a:xfrm>
-              <a:off x="8874817" y="3660749"/>
-              <a:ext cx="692069" cy="461665"/>
-            </a:xfrm>
-            <a:prstGeom prst="rect">
-              <a:avLst/>
-            </a:prstGeom>
-            <a:noFill/>
-          </p:spPr>
-          <p:txBody>
-            <a:bodyPr wrap="square" rtlCol="0">
-              <a:spAutoFit/>
-            </a:bodyPr>
-            <a:lstStyle/>
-            <a:p>
-              <a:r>
-                <a:rPr lang="en-US" sz="2400" noProof="0" dirty="0">
-                  <a:solidFill>
-                    <a:schemeClr val="accent1">
-                      <a:lumMod val="50000"/>
-                    </a:schemeClr>
-                  </a:solidFill>
-                </a:rPr>
-                <a:t>1</a:t>
-              </a:r>
-            </a:p>
-          </p:txBody>
-        </p:sp>
-        <p:sp>
-          <p:nvSpPr>
-            <p:cNvPr id="27" name="TextBox 26">
-              <a:extLst>
-                <a:ext uri="{FF2B5EF4-FFF2-40B4-BE49-F238E27FC236}">
-                  <a16:creationId xmlns:a16="http://schemas.microsoft.com/office/drawing/2014/main" id="{7286F489-3E4B-45D8-17E8-82A0370079DC}"/>
-                </a:ext>
-              </a:extLst>
-            </p:cNvPr>
-            <p:cNvSpPr txBox="1"/>
-            <p:nvPr/>
-          </p:nvSpPr>
-          <p:spPr>
-            <a:xfrm>
-              <a:off x="7093140" y="3281655"/>
-              <a:ext cx="692069" cy="461665"/>
-            </a:xfrm>
-            <a:prstGeom prst="rect">
-              <a:avLst/>
-            </a:prstGeom>
-            <a:noFill/>
-          </p:spPr>
-          <p:txBody>
-            <a:bodyPr wrap="square" rtlCol="0">
-              <a:spAutoFit/>
-            </a:bodyPr>
-            <a:lstStyle/>
-            <a:p>
-              <a:pPr algn="r"/>
-              <a:r>
-                <a:rPr lang="en-US" sz="2400" noProof="0" dirty="0">
-                  <a:solidFill>
-                    <a:schemeClr val="accent1">
-                      <a:lumMod val="50000"/>
-                    </a:schemeClr>
-                  </a:solidFill>
-                </a:rPr>
-                <a:t>3</a:t>
-              </a:r>
-            </a:p>
-          </p:txBody>
-        </p:sp>
-        <p:sp>
-          <p:nvSpPr>
-            <p:cNvPr id="28" name="TextBox 27">
-              <a:extLst>
-                <a:ext uri="{FF2B5EF4-FFF2-40B4-BE49-F238E27FC236}">
-                  <a16:creationId xmlns:a16="http://schemas.microsoft.com/office/drawing/2014/main" id="{AA590F75-E074-0352-1F78-9344C08430A7}"/>
-                </a:ext>
-              </a:extLst>
-            </p:cNvPr>
-            <p:cNvSpPr txBox="1"/>
-            <p:nvPr/>
-          </p:nvSpPr>
-          <p:spPr>
-            <a:xfrm>
-              <a:off x="5346550" y="2793904"/>
-              <a:ext cx="692069" cy="461665"/>
-            </a:xfrm>
-            <a:prstGeom prst="rect">
-              <a:avLst/>
-            </a:prstGeom>
-            <a:noFill/>
-          </p:spPr>
-          <p:txBody>
-            <a:bodyPr wrap="square" rtlCol="0">
-              <a:spAutoFit/>
-            </a:bodyPr>
-            <a:lstStyle/>
-            <a:p>
-              <a:r>
-                <a:rPr lang="en-US" sz="2400" noProof="0" dirty="0">
-                  <a:solidFill>
-                    <a:schemeClr val="accent1">
-                      <a:lumMod val="50000"/>
-                    </a:schemeClr>
-                  </a:solidFill>
-                </a:rPr>
-                <a:t>3</a:t>
-              </a:r>
-            </a:p>
-          </p:txBody>
-        </p:sp>
-        <p:sp>
-          <p:nvSpPr>
-            <p:cNvPr id="29" name="TextBox 28">
-              <a:extLst>
-                <a:ext uri="{FF2B5EF4-FFF2-40B4-BE49-F238E27FC236}">
-                  <a16:creationId xmlns:a16="http://schemas.microsoft.com/office/drawing/2014/main" id="{09476C2E-83CF-713A-49AA-DC684347CA7A}"/>
-                </a:ext>
-              </a:extLst>
-            </p:cNvPr>
-            <p:cNvSpPr txBox="1"/>
-            <p:nvPr/>
-          </p:nvSpPr>
-          <p:spPr>
-            <a:xfrm>
-              <a:off x="5008551" y="3570925"/>
-              <a:ext cx="692069" cy="461665"/>
-            </a:xfrm>
-            <a:prstGeom prst="rect">
-              <a:avLst/>
-            </a:prstGeom>
-            <a:noFill/>
-          </p:spPr>
-          <p:txBody>
-            <a:bodyPr wrap="square" rtlCol="0">
-              <a:spAutoFit/>
-            </a:bodyPr>
-            <a:lstStyle/>
-            <a:p>
-              <a:pPr algn="r"/>
-              <a:r>
-                <a:rPr lang="en-US" sz="2400" noProof="0" dirty="0">
-                  <a:solidFill>
-                    <a:schemeClr val="accent1">
-                      <a:lumMod val="50000"/>
-                    </a:schemeClr>
-                  </a:solidFill>
-                </a:rPr>
-                <a:t>1</a:t>
-              </a:r>
-            </a:p>
-          </p:txBody>
-        </p:sp>
-        <p:sp>
-          <p:nvSpPr>
-            <p:cNvPr id="30" name="TextBox 29">
-              <a:extLst>
-                <a:ext uri="{FF2B5EF4-FFF2-40B4-BE49-F238E27FC236}">
-                  <a16:creationId xmlns:a16="http://schemas.microsoft.com/office/drawing/2014/main" id="{796E68F0-13B5-ED1D-DB93-A0D630FA4CCE}"/>
-                </a:ext>
-              </a:extLst>
-            </p:cNvPr>
-            <p:cNvSpPr txBox="1"/>
-            <p:nvPr/>
-          </p:nvSpPr>
-          <p:spPr>
-            <a:xfrm>
-              <a:off x="1688171" y="3923728"/>
-              <a:ext cx="1157172" cy="461665"/>
-            </a:xfrm>
-            <a:prstGeom prst="rect">
-              <a:avLst/>
-            </a:prstGeom>
-            <a:noFill/>
-          </p:spPr>
-          <p:txBody>
-            <a:bodyPr wrap="square" rtlCol="0">
-              <a:spAutoFit/>
-            </a:bodyPr>
-            <a:lstStyle/>
-            <a:p>
-              <a:pPr algn="ctr"/>
-              <a:r>
-                <a:rPr lang="en-US" sz="2400" noProof="0" dirty="0"/>
-                <a:t>source</a:t>
-              </a:r>
-            </a:p>
-          </p:txBody>
-        </p:sp>
-        <p:sp>
-          <p:nvSpPr>
-            <p:cNvPr id="31" name="TextBox 30">
-              <a:extLst>
-                <a:ext uri="{FF2B5EF4-FFF2-40B4-BE49-F238E27FC236}">
-                  <a16:creationId xmlns:a16="http://schemas.microsoft.com/office/drawing/2014/main" id="{4A7DED31-8126-4432-7444-EB6A222649F0}"/>
-                </a:ext>
-              </a:extLst>
-            </p:cNvPr>
-            <p:cNvSpPr txBox="1"/>
-            <p:nvPr/>
-          </p:nvSpPr>
-          <p:spPr>
-            <a:xfrm>
-              <a:off x="9992198" y="3897412"/>
-              <a:ext cx="1157172" cy="461665"/>
-            </a:xfrm>
-            <a:prstGeom prst="rect">
-              <a:avLst/>
-            </a:prstGeom>
-            <a:noFill/>
-          </p:spPr>
-          <p:txBody>
-            <a:bodyPr wrap="square" rtlCol="0">
-              <a:spAutoFit/>
-            </a:bodyPr>
-            <a:lstStyle/>
-            <a:p>
-              <a:pPr algn="ctr"/>
-              <a:r>
-                <a:rPr lang="en-US" sz="2400" noProof="0" dirty="0"/>
-                <a:t>sink</a:t>
-              </a:r>
-            </a:p>
-          </p:txBody>
-        </p:sp>
-      </p:grpSp>
-      <p:grpSp>
-        <p:nvGrpSpPr>
-          <p:cNvPr id="41" name="Group 40">
-            <a:extLst>
-              <a:ext uri="{FF2B5EF4-FFF2-40B4-BE49-F238E27FC236}">
-                <a16:creationId xmlns:a16="http://schemas.microsoft.com/office/drawing/2014/main" id="{9227A7DD-544A-8F10-A28A-35C31C126161}"/>
-              </a:ext>
-            </a:extLst>
-          </p:cNvPr>
-          <p:cNvGrpSpPr/>
-          <p:nvPr/>
-        </p:nvGrpSpPr>
-        <p:grpSpPr>
-          <a:xfrm>
-            <a:off x="3349114" y="1558043"/>
-            <a:ext cx="6474310" cy="3499508"/>
-            <a:chOff x="2090579" y="1791322"/>
-            <a:chExt cx="6474310" cy="3499508"/>
-          </a:xfrm>
-        </p:grpSpPr>
-        <p:sp>
-          <p:nvSpPr>
-            <p:cNvPr id="42" name="TextBox 41">
-              <a:extLst>
-                <a:ext uri="{FF2B5EF4-FFF2-40B4-BE49-F238E27FC236}">
-                  <a16:creationId xmlns:a16="http://schemas.microsoft.com/office/drawing/2014/main" id="{F722E4A3-B0E5-3D9E-D5C5-EE90B813AC21}"/>
-                </a:ext>
-              </a:extLst>
-            </p:cNvPr>
-            <p:cNvSpPr txBox="1"/>
-            <p:nvPr/>
-          </p:nvSpPr>
-          <p:spPr>
-            <a:xfrm>
-              <a:off x="6678736" y="3380335"/>
-              <a:ext cx="692069" cy="461665"/>
-            </a:xfrm>
-            <a:prstGeom prst="rect">
-              <a:avLst/>
-            </a:prstGeom>
-            <a:noFill/>
-          </p:spPr>
-          <p:txBody>
-            <a:bodyPr wrap="square" rtlCol="0">
-              <a:spAutoFit/>
-            </a:bodyPr>
-            <a:lstStyle/>
-            <a:p>
-              <a:r>
-                <a:rPr lang="en-US" sz="2400" noProof="0" dirty="0">
-                  <a:solidFill>
-                    <a:srgbClr val="00B050"/>
-                  </a:solidFill>
-                </a:rPr>
-                <a:t>= 2</a:t>
-              </a:r>
-            </a:p>
-          </p:txBody>
-        </p:sp>
-        <p:sp>
-          <p:nvSpPr>
-            <p:cNvPr id="43" name="TextBox 42">
-              <a:extLst>
-                <a:ext uri="{FF2B5EF4-FFF2-40B4-BE49-F238E27FC236}">
-                  <a16:creationId xmlns:a16="http://schemas.microsoft.com/office/drawing/2014/main" id="{AF9B88C8-5FDF-A739-CA1C-146A89CBDC8A}"/>
-                </a:ext>
-              </a:extLst>
-            </p:cNvPr>
-            <p:cNvSpPr txBox="1"/>
-            <p:nvPr/>
-          </p:nvSpPr>
-          <p:spPr>
-            <a:xfrm>
-              <a:off x="4765384" y="1791322"/>
-              <a:ext cx="692069" cy="461665"/>
-            </a:xfrm>
-            <a:prstGeom prst="rect">
-              <a:avLst/>
-            </a:prstGeom>
-            <a:noFill/>
-          </p:spPr>
-          <p:txBody>
-            <a:bodyPr wrap="square" rtlCol="0">
-              <a:spAutoFit/>
-            </a:bodyPr>
-            <a:lstStyle/>
-            <a:p>
-              <a:r>
-                <a:rPr lang="en-US" sz="2400" noProof="0" dirty="0">
-                  <a:solidFill>
-                    <a:srgbClr val="00B050"/>
-                  </a:solidFill>
-                </a:rPr>
-                <a:t>= 1</a:t>
-              </a:r>
-            </a:p>
-          </p:txBody>
-        </p:sp>
-        <p:sp>
-          <p:nvSpPr>
-            <p:cNvPr id="44" name="TextBox 43">
-              <a:extLst>
-                <a:ext uri="{FF2B5EF4-FFF2-40B4-BE49-F238E27FC236}">
-                  <a16:creationId xmlns:a16="http://schemas.microsoft.com/office/drawing/2014/main" id="{A8BC47B8-A4E5-C600-6887-6F908ABF8661}"/>
-                </a:ext>
-              </a:extLst>
-            </p:cNvPr>
-            <p:cNvSpPr txBox="1"/>
-            <p:nvPr/>
-          </p:nvSpPr>
-          <p:spPr>
-            <a:xfrm>
-              <a:off x="2109590" y="3785385"/>
-              <a:ext cx="692069" cy="461665"/>
-            </a:xfrm>
-            <a:prstGeom prst="rect">
-              <a:avLst/>
-            </a:prstGeom>
-            <a:noFill/>
-          </p:spPr>
-          <p:txBody>
-            <a:bodyPr wrap="square" rtlCol="0">
-              <a:spAutoFit/>
-            </a:bodyPr>
-            <a:lstStyle/>
-            <a:p>
-              <a:r>
-                <a:rPr lang="en-US" sz="2400" noProof="0" dirty="0">
-                  <a:solidFill>
-                    <a:srgbClr val="00B050"/>
-                  </a:solidFill>
-                </a:rPr>
-                <a:t>= 2</a:t>
-              </a:r>
-            </a:p>
-          </p:txBody>
-        </p:sp>
-        <p:sp>
-          <p:nvSpPr>
-            <p:cNvPr id="45" name="TextBox 44">
-              <a:extLst>
-                <a:ext uri="{FF2B5EF4-FFF2-40B4-BE49-F238E27FC236}">
-                  <a16:creationId xmlns:a16="http://schemas.microsoft.com/office/drawing/2014/main" id="{AF800CEA-4E75-98D3-F85C-41120F98744C}"/>
-                </a:ext>
-              </a:extLst>
-            </p:cNvPr>
-            <p:cNvSpPr txBox="1"/>
-            <p:nvPr/>
-          </p:nvSpPr>
-          <p:spPr>
-            <a:xfrm>
-              <a:off x="4452746" y="3975587"/>
-              <a:ext cx="692069" cy="461665"/>
-            </a:xfrm>
-            <a:prstGeom prst="rect">
-              <a:avLst/>
-            </a:prstGeom>
-            <a:noFill/>
-          </p:spPr>
-          <p:txBody>
-            <a:bodyPr wrap="square" rtlCol="0">
-              <a:spAutoFit/>
-            </a:bodyPr>
-            <a:lstStyle/>
-            <a:p>
-              <a:r>
-                <a:rPr lang="en-US" sz="2400" noProof="0" dirty="0">
-                  <a:solidFill>
-                    <a:srgbClr val="00B050"/>
-                  </a:solidFill>
-                </a:rPr>
-                <a:t>= 1</a:t>
-              </a:r>
-            </a:p>
-          </p:txBody>
-        </p:sp>
-        <p:sp>
-          <p:nvSpPr>
-            <p:cNvPr id="46" name="TextBox 45">
-              <a:extLst>
-                <a:ext uri="{FF2B5EF4-FFF2-40B4-BE49-F238E27FC236}">
-                  <a16:creationId xmlns:a16="http://schemas.microsoft.com/office/drawing/2014/main" id="{62772A9C-90A0-767B-DDFD-ABF323271DD3}"/>
-                </a:ext>
-              </a:extLst>
-            </p:cNvPr>
-            <p:cNvSpPr txBox="1"/>
-            <p:nvPr/>
-          </p:nvSpPr>
-          <p:spPr>
-            <a:xfrm>
-              <a:off x="4545572" y="2667826"/>
-              <a:ext cx="692069" cy="461665"/>
-            </a:xfrm>
-            <a:prstGeom prst="rect">
-              <a:avLst/>
-            </a:prstGeom>
-            <a:noFill/>
-          </p:spPr>
-          <p:txBody>
-            <a:bodyPr wrap="square" rtlCol="0">
-              <a:spAutoFit/>
-            </a:bodyPr>
-            <a:lstStyle/>
-            <a:p>
-              <a:r>
-                <a:rPr lang="en-US" sz="2400" noProof="0" dirty="0">
-                  <a:solidFill>
-                    <a:srgbClr val="00B050"/>
-                  </a:solidFill>
-                </a:rPr>
-                <a:t>= 2</a:t>
-              </a:r>
-            </a:p>
-          </p:txBody>
-        </p:sp>
-        <p:sp>
-          <p:nvSpPr>
-            <p:cNvPr id="47" name="TextBox 46">
-              <a:extLst>
-                <a:ext uri="{FF2B5EF4-FFF2-40B4-BE49-F238E27FC236}">
-                  <a16:creationId xmlns:a16="http://schemas.microsoft.com/office/drawing/2014/main" id="{6B2A33C8-E5BB-D551-8BB5-9028A9BAC4AF}"/>
-                </a:ext>
-              </a:extLst>
-            </p:cNvPr>
-            <p:cNvSpPr txBox="1"/>
-            <p:nvPr/>
-          </p:nvSpPr>
-          <p:spPr>
-            <a:xfrm>
-              <a:off x="2090579" y="2879122"/>
-              <a:ext cx="692069" cy="461665"/>
-            </a:xfrm>
-            <a:prstGeom prst="rect">
-              <a:avLst/>
-            </a:prstGeom>
-            <a:noFill/>
-          </p:spPr>
-          <p:txBody>
-            <a:bodyPr wrap="square" rtlCol="0">
-              <a:spAutoFit/>
-            </a:bodyPr>
-            <a:lstStyle/>
-            <a:p>
-              <a:r>
-                <a:rPr lang="en-US" sz="2400" noProof="0" dirty="0">
-                  <a:solidFill>
-                    <a:srgbClr val="00B050"/>
-                  </a:solidFill>
-                </a:rPr>
-                <a:t>= 3</a:t>
-              </a:r>
-            </a:p>
-          </p:txBody>
-        </p:sp>
-        <p:sp>
-          <p:nvSpPr>
-            <p:cNvPr id="48" name="TextBox 47">
-              <a:extLst>
-                <a:ext uri="{FF2B5EF4-FFF2-40B4-BE49-F238E27FC236}">
-                  <a16:creationId xmlns:a16="http://schemas.microsoft.com/office/drawing/2014/main" id="{EA15AA99-CDAB-75E1-96D4-98CAAAA339A7}"/>
-                </a:ext>
-              </a:extLst>
-            </p:cNvPr>
-            <p:cNvSpPr txBox="1"/>
-            <p:nvPr/>
-          </p:nvSpPr>
-          <p:spPr>
-            <a:xfrm>
-              <a:off x="7811429" y="2244296"/>
-              <a:ext cx="692069" cy="461665"/>
-            </a:xfrm>
-            <a:prstGeom prst="rect">
-              <a:avLst/>
-            </a:prstGeom>
-            <a:noFill/>
-          </p:spPr>
-          <p:txBody>
-            <a:bodyPr wrap="square" rtlCol="0">
-              <a:spAutoFit/>
-            </a:bodyPr>
-            <a:lstStyle/>
-            <a:p>
-              <a:r>
-                <a:rPr lang="en-US" sz="2400" noProof="0" dirty="0">
-                  <a:solidFill>
-                    <a:srgbClr val="00B050"/>
-                  </a:solidFill>
-                </a:rPr>
-                <a:t>= 4</a:t>
-              </a:r>
-            </a:p>
-          </p:txBody>
-        </p:sp>
-        <p:sp>
-          <p:nvSpPr>
-            <p:cNvPr id="49" name="TextBox 48">
-              <a:extLst>
-                <a:ext uri="{FF2B5EF4-FFF2-40B4-BE49-F238E27FC236}">
-                  <a16:creationId xmlns:a16="http://schemas.microsoft.com/office/drawing/2014/main" id="{DBC85C7D-DD8E-BA57-2304-C603DA3A1BC1}"/>
-                </a:ext>
-              </a:extLst>
-            </p:cNvPr>
-            <p:cNvSpPr txBox="1"/>
-            <p:nvPr/>
-          </p:nvSpPr>
-          <p:spPr>
-            <a:xfrm>
-              <a:off x="7872820" y="4247485"/>
-              <a:ext cx="692069" cy="461665"/>
-            </a:xfrm>
-            <a:prstGeom prst="rect">
-              <a:avLst/>
-            </a:prstGeom>
-            <a:noFill/>
-          </p:spPr>
-          <p:txBody>
-            <a:bodyPr wrap="square" rtlCol="0">
-              <a:spAutoFit/>
-            </a:bodyPr>
-            <a:lstStyle/>
-            <a:p>
-              <a:r>
-                <a:rPr lang="en-US" sz="2400" noProof="0" dirty="0">
-                  <a:solidFill>
-                    <a:srgbClr val="00B050"/>
-                  </a:solidFill>
-                </a:rPr>
-                <a:t>= 1</a:t>
-              </a:r>
-            </a:p>
-          </p:txBody>
-        </p:sp>
-        <p:sp>
-          <p:nvSpPr>
-            <p:cNvPr id="50" name="TextBox 49">
-              <a:extLst>
-                <a:ext uri="{FF2B5EF4-FFF2-40B4-BE49-F238E27FC236}">
-                  <a16:creationId xmlns:a16="http://schemas.microsoft.com/office/drawing/2014/main" id="{2A6640B1-6C45-EE68-0419-C3AFBEC2DE71}"/>
-                </a:ext>
-              </a:extLst>
-            </p:cNvPr>
-            <p:cNvSpPr txBox="1"/>
-            <p:nvPr/>
-          </p:nvSpPr>
-          <p:spPr>
-            <a:xfrm>
-              <a:off x="4817104" y="4829165"/>
-              <a:ext cx="692069" cy="461665"/>
-            </a:xfrm>
-            <a:prstGeom prst="rect">
-              <a:avLst/>
-            </a:prstGeom>
-            <a:noFill/>
-          </p:spPr>
-          <p:txBody>
-            <a:bodyPr wrap="square" rtlCol="0">
-              <a:spAutoFit/>
-            </a:bodyPr>
-            <a:lstStyle/>
-            <a:p>
-              <a:r>
-                <a:rPr lang="en-US" sz="2400" noProof="0" dirty="0">
-                  <a:solidFill>
-                    <a:srgbClr val="00B050"/>
-                  </a:solidFill>
-                </a:rPr>
-                <a:t>= 1</a:t>
-              </a:r>
-            </a:p>
-          </p:txBody>
-        </p:sp>
-      </p:grpSp>
-    </p:spTree>
-    <p:extLst>
-      <p:ext uri="{BB962C8B-B14F-4D97-AF65-F5344CB8AC3E}">
-        <p14:creationId xmlns:p14="http://schemas.microsoft.com/office/powerpoint/2010/main" val="481070028"/>
-      </p:ext>
-    </p:extLst>
-  </p:cSld>
-  <p:clrMapOvr>
-    <a:masterClrMapping/>
-  </p:clrMapOvr>
-  <p:timing>
-    <p:tnLst>
-      <p:par>
-        <p:cTn id="1" dur="indefinite" restart="never" nodeType="tmRoot">
-          <p:childTnLst>
-            <p:seq concurrent="1" nextAc="seek">
-              <p:cTn id="2" dur="indefinite" nodeType="mainSeq">
-                <p:childTnLst>
-                  <p:par>
-                    <p:cTn id="3" fill="hold">
-                      <p:stCondLst>
-                        <p:cond delay="indefinite"/>
-                      </p:stCondLst>
-                      <p:childTnLst>
-                        <p:par>
-                          <p:cTn id="4" fill="hold">
-                            <p:stCondLst>
-                              <p:cond delay="0"/>
-                            </p:stCondLst>
-                            <p:childTnLst>
-                              <p:par>
-                                <p:cTn id="5" presetID="10" presetClass="entr" presetSubtype="0" fill="hold" nodeType="clickEffect">
-                                  <p:stCondLst>
-                                    <p:cond delay="0"/>
-                                  </p:stCondLst>
-                                  <p:childTnLst>
-                                    <p:set>
-                                      <p:cBhvr>
-                                        <p:cTn id="6" dur="1" fill="hold">
-                                          <p:stCondLst>
-                                            <p:cond delay="0"/>
-                                          </p:stCondLst>
-                                        </p:cTn>
-                                        <p:tgtEl>
-                                          <p:spTgt spid="41"/>
-                                        </p:tgtEl>
-                                        <p:attrNameLst>
-                                          <p:attrName>style.visibility</p:attrName>
-                                        </p:attrNameLst>
-                                      </p:cBhvr>
-                                      <p:to>
-                                        <p:strVal val="visible"/>
-                                      </p:to>
-                                    </p:set>
-                                    <p:animEffect transition="in" filter="fade">
-                                      <p:cBhvr>
-                                        <p:cTn id="7" dur="500"/>
-                                        <p:tgtEl>
-                                          <p:spTgt spid="41"/>
-                                        </p:tgtEl>
-                                      </p:cBhvr>
-                                    </p:animEffect>
-                                  </p:childTnLst>
-                                </p:cTn>
-                              </p:par>
-                            </p:childTnLst>
-                          </p:cTn>
-                        </p:par>
-                      </p:childTnLst>
-                    </p:cTn>
-                  </p:par>
-                </p:childTnLst>
-              </p:cTn>
-              <p:prevCondLst>
-                <p:cond evt="onPrev" delay="0">
-                  <p:tgtEl>
-                    <p:sldTgt/>
-                  </p:tgtEl>
-                </p:cond>
-              </p:prevCondLst>
-              <p:nextCondLst>
-                <p:cond evt="onNext" delay="0">
-                  <p:tgtEl>
-                    <p:sldTgt/>
-                  </p:tgtEl>
-                </p:cond>
-              </p:nextCondLst>
-            </p:seq>
-          </p:childTnLst>
-        </p:cTn>
-      </p:par>
-    </p:tnLst>
-  </p:timing>
-</p:sld>
-</file>
-
-<file path=ppt/slides/slide22.xml><?xml version="1.0" encoding="utf-8"?>
-<p:sld xmlns:a="http://schemas.openxmlformats.org/drawingml/2006/main" xmlns:r="http://schemas.openxmlformats.org/officeDocument/2006/relationships" xmlns:p="http://schemas.openxmlformats.org/presentationml/2006/main">
-  <p:cSld>
-    <p:spTree>
-      <p:nvGrpSpPr>
-        <p:cNvPr id="1" name=""/>
-        <p:cNvGrpSpPr/>
-        <p:nvPr/>
-      </p:nvGrpSpPr>
-      <p:grpSpPr>
-        <a:xfrm>
-          <a:off x="0" y="0"/>
-          <a:ext cx="0" cy="0"/>
-          <a:chOff x="0" y="0"/>
-          <a:chExt cx="0" cy="0"/>
-        </a:xfrm>
-      </p:grpSpPr>
       <p:sp>
         <p:nvSpPr>
           <p:cNvPr id="3" name="Content Placeholder 2"/>
@@ -24205,8 +22043,8 @@
           </p:txBody>
         </p:sp>
       </p:grpSp>
-      <mc:AlternateContent xmlns:mc="http://schemas.openxmlformats.org/markup-compatibility/2006">
-        <mc:Choice xmlns:a14="http://schemas.microsoft.com/office/drawing/2010/main" Requires="a14">
+      <mc:AlternateContent xmlns:mc="http://schemas.openxmlformats.org/markup-compatibility/2006" xmlns:a14="http://schemas.microsoft.com/office/drawing/2010/main">
+        <mc:Choice Requires="a14">
           <p:sp>
             <p:nvSpPr>
               <p:cNvPr id="26" name="TextBox 25"/>
@@ -24256,7 +22094,7 @@
             </p:txBody>
           </p:sp>
         </mc:Choice>
-        <mc:Fallback>
+        <mc:Fallback xmlns="">
           <p:sp>
             <p:nvSpPr>
               <p:cNvPr id="26" name="TextBox 25"/>
@@ -24459,7 +22297,7 @@
 </p:sld>
 </file>
 
-<file path=ppt/slides/slide23.xml><?xml version="1.0" encoding="utf-8"?>
+<file path=ppt/slides/slide22.xml><?xml version="1.0" encoding="utf-8"?>
 <p:sld xmlns:a="http://schemas.openxmlformats.org/drawingml/2006/main" xmlns:r="http://schemas.openxmlformats.org/officeDocument/2006/relationships" xmlns:p="http://schemas.openxmlformats.org/presentationml/2006/main">
   <p:cSld>
     <p:spTree>
@@ -25916,7 +23754,7 @@
 </p:sld>
 </file>
 
-<file path=ppt/slides/slide24.xml><?xml version="1.0" encoding="utf-8"?>
+<file path=ppt/slides/slide23.xml><?xml version="1.0" encoding="utf-8"?>
 <p:sld xmlns:a="http://schemas.openxmlformats.org/drawingml/2006/main" xmlns:r="http://schemas.openxmlformats.org/officeDocument/2006/relationships" xmlns:p="http://schemas.openxmlformats.org/presentationml/2006/main">
   <p:cSld>
     <p:spTree>
@@ -26003,7 +23841,7 @@
 </p:sld>
 </file>
 
-<file path=ppt/slides/slide25.xml><?xml version="1.0" encoding="utf-8"?>
+<file path=ppt/slides/slide24.xml><?xml version="1.0" encoding="utf-8"?>
 <p:sld xmlns:a="http://schemas.openxmlformats.org/drawingml/2006/main" xmlns:r="http://schemas.openxmlformats.org/officeDocument/2006/relationships" xmlns:p="http://schemas.openxmlformats.org/presentationml/2006/main">
   <p:cSld>
     <p:spTree>
@@ -27335,7 +25173,7 @@
 </p:sld>
 </file>
 
-<file path=ppt/slides/slide26.xml><?xml version="1.0" encoding="utf-8"?>
+<file path=ppt/slides/slide25.xml><?xml version="1.0" encoding="utf-8"?>
 <p:sld xmlns:a="http://schemas.openxmlformats.org/drawingml/2006/main" xmlns:r="http://schemas.openxmlformats.org/officeDocument/2006/relationships" xmlns:p="http://schemas.openxmlformats.org/presentationml/2006/main">
   <p:cSld>
     <p:spTree>

</xml_diff>

<commit_message>
all-slides-with-answers.pdf all-slides.pdf linear_programming.pdf linear_programming.pptx
</commit_message>
<xml_diff>
--- a/ipsa/slides/linear_programming.pptx
+++ b/ipsa/slides/linear_programming.pptx
@@ -142,7 +142,7 @@
 <file path=ppt/revisionInfo.xml><?xml version="1.0" encoding="utf-8"?>
 <p1510:revInfo xmlns:a="http://schemas.openxmlformats.org/drawingml/2006/main" xmlns:r="http://schemas.openxmlformats.org/officeDocument/2006/relationships" xmlns:p1510="http://schemas.microsoft.com/office/powerpoint/2015/10/main">
   <p1510:revLst>
-    <p1510:client id="{A01180FA-6CD6-4EEE-8D0C-E201AD20255F}" v="81" dt="2026-04-12T22:24:46.755"/>
+    <p1510:client id="{A01180FA-6CD6-4EEE-8D0C-E201AD20255F}" v="82" dt="2026-04-13T11:20:45.998"/>
   </p1510:revLst>
 </p1510:revInfo>
 </file>
@@ -152,7 +152,7 @@
   <pc:docChgLst>
     <pc:chgData name="Gerth Stølting Brodal" userId="04ef4784-6591-4f86-a140-f5c3b108582a" providerId="ADAL" clId="{73BAC7D6-516A-44B5-B4B0-C7B08CA8B392}"/>
     <pc:docChg chg="undo redo custSel addSld delSld modSld">
-      <pc:chgData name="Gerth Stølting Brodal" userId="04ef4784-6591-4f86-a140-f5c3b108582a" providerId="ADAL" clId="{73BAC7D6-516A-44B5-B4B0-C7B08CA8B392}" dt="2026-04-13T08:13:57.206" v="3013" actId="47"/>
+      <pc:chgData name="Gerth Stølting Brodal" userId="04ef4784-6591-4f86-a140-f5c3b108582a" providerId="ADAL" clId="{73BAC7D6-516A-44B5-B4B0-C7B08CA8B392}" dt="2026-04-13T11:21:48.139" v="3016" actId="20577"/>
       <pc:docMkLst>
         <pc:docMk/>
       </pc:docMkLst>
@@ -1479,7 +1479,7 @@
         </pc:spChg>
       </pc:sldChg>
       <pc:sldChg chg="addSp delSp modSp mod addAnim delAnim modAnim modShow modNotesTx">
-        <pc:chgData name="Gerth Stølting Brodal" userId="04ef4784-6591-4f86-a140-f5c3b108582a" providerId="ADAL" clId="{73BAC7D6-516A-44B5-B4B0-C7B08CA8B392}" dt="2026-04-12T22:25:47.322" v="2909" actId="27636"/>
+        <pc:chgData name="Gerth Stølting Brodal" userId="04ef4784-6591-4f86-a140-f5c3b108582a" providerId="ADAL" clId="{73BAC7D6-516A-44B5-B4B0-C7B08CA8B392}" dt="2026-04-13T11:21:48.139" v="3016" actId="20577"/>
         <pc:sldMkLst>
           <pc:docMk/>
           <pc:sldMk cId="3577428823" sldId="798"/>
@@ -1493,7 +1493,7 @@
           </ac:spMkLst>
         </pc:spChg>
         <pc:spChg chg="mod">
-          <ac:chgData name="Gerth Stølting Brodal" userId="04ef4784-6591-4f86-a140-f5c3b108582a" providerId="ADAL" clId="{73BAC7D6-516A-44B5-B4B0-C7B08CA8B392}" dt="2026-04-12T22:25:47.322" v="2909" actId="27636"/>
+          <ac:chgData name="Gerth Stølting Brodal" userId="04ef4784-6591-4f86-a140-f5c3b108582a" providerId="ADAL" clId="{73BAC7D6-516A-44B5-B4B0-C7B08CA8B392}" dt="2026-04-13T11:21:48.139" v="3016" actId="20577"/>
           <ac:spMkLst>
             <pc:docMk/>
             <pc:sldMk cId="3577428823" sldId="798"/>
@@ -23957,7 +23957,7 @@
           <a:p>
             <a:r>
               <a:rPr lang="en-US" dirty="0"/>
-              <a:t>Open source solver: </a:t>
+              <a:t>Open-source solver: </a:t>
             </a:r>
             <a:r>
               <a:rPr lang="en-US" dirty="0" err="1"/>
@@ -25087,89 +25087,6 @@
   <p:clrMapOvr>
     <a:masterClrMapping/>
   </p:clrMapOvr>
-  <p:timing>
-    <p:tnLst>
-      <p:par>
-        <p:cTn id="1" dur="indefinite" restart="never" nodeType="tmRoot">
-          <p:childTnLst>
-            <p:seq concurrent="1" nextAc="seek">
-              <p:cTn id="2" dur="indefinite" nodeType="mainSeq">
-                <p:childTnLst>
-                  <p:par>
-                    <p:cTn id="3" fill="hold">
-                      <p:stCondLst>
-                        <p:cond delay="indefinite"/>
-                      </p:stCondLst>
-                      <p:childTnLst>
-                        <p:par>
-                          <p:cTn id="4" fill="hold">
-                            <p:stCondLst>
-                              <p:cond delay="0"/>
-                            </p:stCondLst>
-                            <p:childTnLst>
-                              <p:par>
-                                <p:cTn id="5" presetID="10" presetClass="entr" presetSubtype="0" fill="hold" nodeType="clickEffect">
-                                  <p:stCondLst>
-                                    <p:cond delay="0"/>
-                                  </p:stCondLst>
-                                  <p:childTnLst>
-                                    <p:set>
-                                      <p:cBhvr>
-                                        <p:cTn id="6" dur="1" fill="hold">
-                                          <p:stCondLst>
-                                            <p:cond delay="0"/>
-                                          </p:stCondLst>
-                                        </p:cTn>
-                                        <p:tgtEl>
-                                          <p:spTgt spid="4"/>
-                                        </p:tgtEl>
-                                        <p:attrNameLst>
-                                          <p:attrName>style.visibility</p:attrName>
-                                        </p:attrNameLst>
-                                      </p:cBhvr>
-                                      <p:to>
-                                        <p:strVal val="visible"/>
-                                      </p:to>
-                                    </p:set>
-                                    <p:animEffect transition="in" filter="fade">
-                                      <p:cBhvr>
-                                        <p:cTn id="7" dur="500"/>
-                                        <p:tgtEl>
-                                          <p:spTgt spid="4"/>
-                                        </p:tgtEl>
-                                      </p:cBhvr>
-                                    </p:animEffect>
-                                  </p:childTnLst>
-                                </p:cTn>
-                              </p:par>
-                            </p:childTnLst>
-                          </p:cTn>
-                        </p:par>
-                      </p:childTnLst>
-                    </p:cTn>
-                  </p:par>
-                </p:childTnLst>
-              </p:cTn>
-              <p:prevCondLst>
-                <p:cond evt="onPrev" delay="0">
-                  <p:tgtEl>
-                    <p:sldTgt/>
-                  </p:tgtEl>
-                </p:cond>
-              </p:prevCondLst>
-              <p:nextCondLst>
-                <p:cond evt="onNext" delay="0">
-                  <p:tgtEl>
-                    <p:sldTgt/>
-                  </p:tgtEl>
-                </p:cond>
-              </p:nextCondLst>
-            </p:seq>
-          </p:childTnLst>
-        </p:cTn>
-      </p:par>
-    </p:tnLst>
-  </p:timing>
 </p:sld>
 </file>
 

</xml_diff>